<commit_message>
Rebuild Lecture-2 with charts and visual layouts
5 embedded images: scatter plot with regression line, equation diagram,
metrics cards, anomaly detection baseline, non-linear limitation chart.
Uses 2-Column, Bullets+Pull Quote, and Title Only layouts.
</commit_message>
<xml_diff>
--- a/stage1_classic_ml/02_linear_regression/Lecture-2-Linear-Regression.pptx
+++ b/stage1_classic_ml/02_linear_regression/Lecture-2-Linear-Regression.pptx
@@ -27,6 +27,10 @@
     <p:sldId id="269" r:id="rId25"/>
     <p:sldId id="270" r:id="rId26"/>
     <p:sldId id="271" r:id="rId27"/>
+    <p:sldId id="272" r:id="rId28"/>
+    <p:sldId id="273" r:id="rId29"/>
+    <p:sldId id="274" r:id="rId30"/>
+    <p:sldId id="275" r:id="rId31"/>
   </p:sldIdLst>
   <p:sldSz cx="12188825" cy="6858000"/>
   <p:notesSz cx="7010400" cy="9296400"/>
@@ -8411,7 +8415,7 @@
           <a:lstStyle/>
           <a:p>
             <a:r>
-              <a:t>Regression Metrics</a:t>
+              <a:t>Fitting and Predicting — The sklearn API</a:t>
             </a:r>
           </a:p>
         </p:txBody>
@@ -8433,43 +8437,61 @@
           <a:p>
             <a:pPr/>
             <a:r>
-              <a:t>R² (R-squared) — how well the line fits the data</a:t>
+              <a:t>Split first — never evaluate on training data:</a:t>
             </a:r>
           </a:p>
           <a:p>
             <a:pPr lvl="1"/>
             <a:r>
-              <a:t>1.0 = perfect fit, 0 = no better than predicting the mean</a:t>
+              <a:t>X_train, X_test, y_train, y_test = train_test_split(X, y, test_size=0.2)</a:t>
             </a:r>
           </a:p>
           <a:p>
             <a:pPr/>
-            <a:r>
-              <a:t>RMSE (Root Mean Squared Error) — average error in same units as target</a:t>
+          </a:p>
+          <a:p>
+            <a:pPr/>
+            <a:r>
+              <a:t>Then fit and predict:</a:t>
             </a:r>
           </a:p>
           <a:p>
             <a:pPr lvl="1"/>
             <a:r>
-              <a:t>RMSE = 25ms means predictions are off by ~25ms on average</a:t>
+              <a:t>model = LinearRegression()</a:t>
+            </a:r>
+          </a:p>
+          <a:p>
+            <a:pPr lvl="1"/>
+            <a:r>
+              <a:t>model.fit(X_train, y_train)     — learn the line</a:t>
+            </a:r>
+          </a:p>
+          <a:p>
+            <a:pPr lvl="1"/>
+            <a:r>
+              <a:t>y_pred = model.predict(X_test)  — predict on unseen data</a:t>
             </a:r>
           </a:p>
           <a:p>
             <a:pPr/>
-            <a:r>
-              <a:t>MAE (Mean Absolute Error) — similar to RMSE, less sensitive to outliers</a:t>
-            </a:r>
           </a:p>
           <a:p>
             <a:pPr/>
             <a:r>
-              <a:t>On clean synthetic data, expect R² close to 1.0</a:t>
-            </a:r>
-          </a:p>
-          <a:p>
-            <a:pPr/>
-            <a:r>
-              <a:t>On real-world data, R² &gt; 0.7 is often considered good</a:t>
+              <a:t>Inspect what the model learned:</a:t>
+            </a:r>
+          </a:p>
+          <a:p>
+            <a:pPr lvl="1"/>
+            <a:r>
+              <a:t>model.coef_       — the slope (ms per req/s)</a:t>
+            </a:r>
+          </a:p>
+          <a:p>
+            <a:pPr lvl="1"/>
+            <a:r>
+              <a:t>model.intercept_  — baseline response time</a:t>
             </a:r>
           </a:p>
         </p:txBody>
@@ -8494,12 +8516,12 @@
       <p:grpSpPr/>
       <p:sp>
         <p:nvSpPr>
-          <p:cNvPr id="2" name="Title 1"/>
+          <p:cNvPr id="2" name="Text Placeholder 1"/>
           <p:cNvSpPr>
             <a:spLocks noGrp="1"/>
           </p:cNvSpPr>
           <p:nvPr>
-            <p:ph type="title"/>
+            <p:ph type="body" idx="13" sz="quarter"/>
           </p:nvPr>
         </p:nvSpPr>
         <p:spPr/>
@@ -8508,19 +8530,24 @@
           <a:lstStyle/>
           <a:p>
             <a:r>
-              <a:t>Security Application: Anomaly Baseline</a:t>
-            </a:r>
-          </a:p>
-        </p:txBody>
-      </p:sp>
-      <p:sp>
-        <p:nvSpPr>
-          <p:cNvPr id="3" name="Content Placeholder 2"/>
+              <a:t>Evaluating</a:t>
+            </a:r>
+          </a:p>
+          <a:p>
+            <a:r>
+              <a:t>the Model</a:t>
+            </a:r>
+          </a:p>
+        </p:txBody>
+      </p:sp>
+      <p:sp>
+        <p:nvSpPr>
+          <p:cNvPr id="3" name="Text Placeholder 2"/>
           <p:cNvSpPr>
             <a:spLocks noGrp="1"/>
           </p:cNvSpPr>
           <p:nvPr>
-            <p:ph idx="1"/>
+            <p:ph type="body" idx="16" sz="quarter"/>
           </p:nvPr>
         </p:nvSpPr>
         <p:spPr/>
@@ -8528,45 +8555,8 @@
           <a:bodyPr/>
           <a:lstStyle/>
           <a:p>
-            <a:pPr/>
-            <a:r>
-              <a:t>Once you have a trained model, you have a baseline:</a:t>
-            </a:r>
-          </a:p>
-          <a:p>
-            <a:pPr/>
-            <a:r>
-              <a:t>For any traffic level, the model predicts 'expected' response time</a:t>
-            </a:r>
-          </a:p>
-          <a:p>
-            <a:pPr/>
-            <a:r>
-              <a:t>Compare actual vs predicted:</a:t>
-            </a:r>
-          </a:p>
-          <a:p>
-            <a:pPr lvl="1"/>
-            <a:r>
-              <a:t>actual - predicted = residual</a:t>
-            </a:r>
-          </a:p>
-          <a:p>
-            <a:pPr/>
-            <a:r>
-              <a:t>Large positive residual → server slower than expected → investigate</a:t>
-            </a:r>
-          </a:p>
-          <a:p>
-            <a:pPr lvl="1"/>
-            <a:r>
-              <a:t>Possible causes: DoS attack, resource exhaustion, crypto mining</a:t>
-            </a:r>
-          </a:p>
-          <a:p>
-            <a:pPr/>
-            <a:r>
-              <a:t>This simple technique powers many production anomaly detectors</a:t>
+            <a:r>
+              <a:t>04</a:t>
             </a:r>
           </a:p>
         </p:txBody>
@@ -8591,12 +8581,12 @@
       <p:grpSpPr/>
       <p:sp>
         <p:nvSpPr>
-          <p:cNvPr id="2" name="Text Placeholder 1"/>
+          <p:cNvPr id="2" name="Title 1"/>
           <p:cNvSpPr>
             <a:spLocks noGrp="1"/>
           </p:cNvSpPr>
           <p:nvPr>
-            <p:ph type="body" idx="13" sz="quarter"/>
+            <p:ph type="title"/>
           </p:nvPr>
         </p:nvSpPr>
         <p:spPr/>
@@ -8605,37 +8595,35 @@
           <a:lstStyle/>
           <a:p>
             <a:r>
-              <a:t>Limitations &amp;</a:t>
-            </a:r>
-          </a:p>
-          <a:p>
-            <a:r>
-              <a:t>Workshop</a:t>
-            </a:r>
-          </a:p>
-        </p:txBody>
-      </p:sp>
-      <p:sp>
-        <p:nvSpPr>
-          <p:cNvPr id="3" name="Text Placeholder 2"/>
-          <p:cNvSpPr>
-            <a:spLocks noGrp="1"/>
-          </p:cNvSpPr>
-          <p:nvPr>
-            <p:ph type="body" idx="16" sz="quarter"/>
-          </p:nvPr>
-        </p:nvSpPr>
-        <p:spPr/>
-        <p:txBody>
-          <a:bodyPr/>
-          <a:lstStyle/>
-          <a:p>
-            <a:r>
-              <a:t>04</a:t>
-            </a:r>
-          </a:p>
-        </p:txBody>
-      </p:sp>
+              <a:t>Regression Evaluation Metrics</a:t>
+            </a:r>
+          </a:p>
+        </p:txBody>
+      </p:sp>
+      <p:pic>
+        <p:nvPicPr>
+          <p:cNvPr id="3" name="Picture 2" descr="lr_metrics.png"/>
+          <p:cNvPicPr>
+            <a:picLocks noChangeAspect="1"/>
+          </p:cNvPicPr>
+          <p:nvPr/>
+        </p:nvPicPr>
+        <p:blipFill>
+          <a:blip r:embed="rId2"/>
+          <a:stretch>
+            <a:fillRect/>
+          </a:stretch>
+        </p:blipFill>
+        <p:spPr>
+          <a:xfrm>
+            <a:off x="1371600" y="1371600"/>
+            <a:ext cx="9418320" cy="4875087"/>
+          </a:xfrm>
+          <a:prstGeom prst="rect">
+            <a:avLst/>
+          </a:prstGeom>
+        </p:spPr>
+      </p:pic>
     </p:spTree>
   </p:cSld>
   <p:clrMapOvr>
@@ -8656,12 +8644,12 @@
       <p:grpSpPr/>
       <p:sp>
         <p:nvSpPr>
-          <p:cNvPr id="2" name="Title 1"/>
+          <p:cNvPr id="2" name="Text Placeholder 1"/>
           <p:cNvSpPr>
             <a:spLocks noGrp="1"/>
           </p:cNvSpPr>
           <p:nvPr>
-            <p:ph type="title"/>
+            <p:ph type="body" idx="13" sz="quarter"/>
           </p:nvPr>
         </p:nvSpPr>
         <p:spPr/>
@@ -8670,19 +8658,24 @@
           <a:lstStyle/>
           <a:p>
             <a:r>
-              <a:t>Limitations of Linear Regression</a:t>
-            </a:r>
-          </a:p>
-        </p:txBody>
-      </p:sp>
-      <p:sp>
-        <p:nvSpPr>
-          <p:cNvPr id="3" name="Content Placeholder 2"/>
+              <a:t>Security Application:</a:t>
+            </a:r>
+          </a:p>
+          <a:p>
+            <a:r>
+              <a:t>Anomaly Detection</a:t>
+            </a:r>
+          </a:p>
+        </p:txBody>
+      </p:sp>
+      <p:sp>
+        <p:nvSpPr>
+          <p:cNvPr id="3" name="Text Placeholder 2"/>
           <p:cNvSpPr>
             <a:spLocks noGrp="1"/>
           </p:cNvSpPr>
           <p:nvPr>
-            <p:ph idx="1"/>
+            <p:ph type="body" idx="16" sz="quarter"/>
           </p:nvPr>
         </p:nvSpPr>
         <p:spPr/>
@@ -8690,39 +8683,8 @@
           <a:bodyPr/>
           <a:lstStyle/>
           <a:p>
-            <a:pPr/>
-            <a:r>
-              <a:t>Only captures linear relationships</a:t>
-            </a:r>
-          </a:p>
-          <a:p>
-            <a:pPr/>
-            <a:r>
-              <a:t>Real servers often behave non-linearly:</a:t>
-            </a:r>
-          </a:p>
-          <a:p>
-            <a:pPr lvl="1"/>
-            <a:r>
-              <a:t>Fine at low load, then suddenly slow past a threshold</a:t>
-            </a:r>
-          </a:p>
-          <a:p>
-            <a:pPr/>
-            <a:r>
-              <a:t>Cannot classify — it predicts a number, not a category</a:t>
-            </a:r>
-          </a:p>
-          <a:p>
-            <a:pPr lvl="1"/>
-            <a:r>
-              <a:t>For binary decisions (attack/benign), use logistic regression (Lesson 1.3)</a:t>
-            </a:r>
-          </a:p>
-          <a:p>
-            <a:pPr/>
-            <a:r>
-              <a:t>For complex non-linear patterns, use neural networks (Stage 3)</a:t>
+            <a:r>
+              <a:t>05</a:t>
             </a:r>
           </a:p>
         </p:txBody>
@@ -8761,75 +8723,35 @@
           <a:lstStyle/>
           <a:p>
             <a:r>
-              <a:t>Workshop — 4 Exercises</a:t>
-            </a:r>
-          </a:p>
-        </p:txBody>
-      </p:sp>
-      <p:sp>
-        <p:nvSpPr>
-          <p:cNvPr id="3" name="Content Placeholder 2"/>
-          <p:cNvSpPr>
-            <a:spLocks noGrp="1"/>
-          </p:cNvSpPr>
-          <p:nvPr>
-            <p:ph idx="1"/>
-          </p:nvPr>
-        </p:nvSpPr>
-        <p:spPr/>
-        <p:txBody>
-          <a:bodyPr/>
-          <a:lstStyle/>
-          <a:p>
-            <a:pPr/>
-            <a:r>
-              <a:t>Exercise 1: Understanding regression — the dataset, visualising the relationship</a:t>
-            </a:r>
-          </a:p>
-          <a:p>
-            <a:pPr/>
-            <a:r>
-              <a:t>Exercise 2: Train/test split — why we split, the danger of evaluating on training data</a:t>
-            </a:r>
-          </a:p>
-          <a:p>
-            <a:pPr/>
-            <a:r>
-              <a:t>Exercise 3: Fit and predict — model.fit(), slope and intercept, visualise the line</a:t>
-            </a:r>
-          </a:p>
-          <a:p>
-            <a:pPr/>
-            <a:r>
-              <a:t>Exercise 4: Evaluate — MSE, RMSE, MAE, R², build a security baseline</a:t>
-            </a:r>
-          </a:p>
-          <a:p>
-            <a:pPr/>
-            <a:r>
-              <a:t>Each exercise has:</a:t>
-            </a:r>
-          </a:p>
-          <a:p>
-            <a:pPr lvl="1"/>
-            <a:r>
-              <a:t>lecture.md — concept explanation</a:t>
-            </a:r>
-          </a:p>
-          <a:p>
-            <a:pPr lvl="1"/>
-            <a:r>
-              <a:t>handson.md — step-by-step lab</a:t>
-            </a:r>
-          </a:p>
-          <a:p>
-            <a:pPr lvl="1"/>
-            <a:r>
-              <a:t>solution_linear_regression.py — reference implementation</a:t>
-            </a:r>
-          </a:p>
-        </p:txBody>
-      </p:sp>
+              <a:t>Building an Anomaly Baseline from the Regression Line</a:t>
+            </a:r>
+          </a:p>
+        </p:txBody>
+      </p:sp>
+      <p:pic>
+        <p:nvPicPr>
+          <p:cNvPr id="3" name="Picture 2" descr="lr_anomaly.png"/>
+          <p:cNvPicPr>
+            <a:picLocks noChangeAspect="1"/>
+          </p:cNvPicPr>
+          <p:nvPr/>
+        </p:nvPicPr>
+        <p:blipFill>
+          <a:blip r:embed="rId2"/>
+          <a:stretch>
+            <a:fillRect/>
+          </a:stretch>
+        </p:blipFill>
+        <p:spPr>
+          <a:xfrm>
+            <a:off x="1554480" y="1371600"/>
+            <a:ext cx="9144000" cy="5075241"/>
+          </a:xfrm>
+          <a:prstGeom prst="rect">
+            <a:avLst/>
+          </a:prstGeom>
+        </p:spPr>
+      </p:pic>
     </p:spTree>
   </p:cSld>
   <p:clrMapOvr>
@@ -8850,59 +8772,7 @@
       <p:grpSpPr/>
       <p:sp>
         <p:nvSpPr>
-          <p:cNvPr id="2" name="Text Placeholder 1"/>
-          <p:cNvSpPr>
-            <a:spLocks noGrp="1"/>
-          </p:cNvSpPr>
-          <p:nvPr>
-            <p:ph type="body" idx="12" sz="quarter"/>
-          </p:nvPr>
-        </p:nvSpPr>
-        <p:spPr/>
-        <p:txBody>
-          <a:bodyPr/>
-          <a:lstStyle/>
-          <a:p>
-            <a:pPr/>
-            <a:r>
-              <a:t>Linear regression predicts a continuous value: y = weight × x + bias</a:t>
-            </a:r>
-          </a:p>
-          <a:p>
-            <a:pPr/>
-            <a:r>
-              <a:t>The model learns weight and bias by minimising prediction error</a:t>
-            </a:r>
-          </a:p>
-          <a:p>
-            <a:pPr/>
-            <a:r>
-              <a:t>R² measures fit quality; RMSE measures average error in real units</a:t>
-            </a:r>
-          </a:p>
-          <a:p>
-            <a:pPr/>
-            <a:r>
-              <a:t>Always split data into train/test before fitting</a:t>
-            </a:r>
-          </a:p>
-          <a:p>
-            <a:pPr/>
-            <a:r>
-              <a:t>Security use: build a baseline, flag anomalies when actual &gt;&gt; predicted</a:t>
-            </a:r>
-          </a:p>
-          <a:p>
-            <a:pPr/>
-            <a:r>
-              <a:t>Next: Lesson 1.3 — Logistic Regression (binary classification)</a:t>
-            </a:r>
-          </a:p>
-        </p:txBody>
-      </p:sp>
-      <p:sp>
-        <p:nvSpPr>
-          <p:cNvPr id="3" name="Title 2"/>
+          <p:cNvPr id="2" name="Title 1"/>
           <p:cNvSpPr>
             <a:spLocks noGrp="1"/>
           </p:cNvSpPr>
@@ -8916,7 +8786,86 @@
           <a:lstStyle/>
           <a:p>
             <a:r>
-              <a:t>Summary</a:t>
+              <a:t>How the Baseline Works</a:t>
+            </a:r>
+          </a:p>
+        </p:txBody>
+      </p:sp>
+      <p:sp>
+        <p:nvSpPr>
+          <p:cNvPr id="3" name="Content Placeholder 2"/>
+          <p:cNvSpPr>
+            <a:spLocks noGrp="1"/>
+          </p:cNvSpPr>
+          <p:nvPr>
+            <p:ph idx="1"/>
+          </p:nvPr>
+        </p:nvSpPr>
+        <p:spPr/>
+        <p:txBody>
+          <a:bodyPr/>
+          <a:lstStyle/>
+          <a:p>
+            <a:pPr/>
+            <a:r>
+              <a:t>Once trained, the model predicts 'expected' response time for any traffic level</a:t>
+            </a:r>
+          </a:p>
+          <a:p>
+            <a:pPr/>
+            <a:r>
+              <a:t>Compare actual vs predicted:</a:t>
+            </a:r>
+          </a:p>
+          <a:p>
+            <a:pPr lvl="1"/>
+            <a:r>
+              <a:t>residual = actual − predicted</a:t>
+            </a:r>
+          </a:p>
+          <a:p>
+            <a:pPr lvl="1"/>
+            <a:r>
+              <a:t>Small residual → normal behaviour</a:t>
+            </a:r>
+          </a:p>
+          <a:p>
+            <a:pPr lvl="1"/>
+            <a:r>
+              <a:t>Large positive residual → server slower than expected → investigate</a:t>
+            </a:r>
+          </a:p>
+          <a:p>
+            <a:pPr/>
+          </a:p>
+          <a:p>
+            <a:pPr/>
+            <a:r>
+              <a:t>Possible causes flagged by anomaly:</a:t>
+            </a:r>
+          </a:p>
+          <a:p>
+            <a:pPr lvl="1"/>
+            <a:r>
+              <a:t>DoS attack saturating resources</a:t>
+            </a:r>
+          </a:p>
+          <a:p>
+            <a:pPr lvl="1"/>
+            <a:r>
+              <a:t>Crypto mining consuming CPU</a:t>
+            </a:r>
+          </a:p>
+          <a:p>
+            <a:pPr lvl="1"/>
+            <a:r>
+              <a:t>Runaway process or memory leak</a:t>
+            </a:r>
+          </a:p>
+          <a:p>
+            <a:pPr/>
+            <a:r>
+              <a:t>This simple technique powers many production anomaly detectors</a:t>
             </a:r>
           </a:p>
         </p:txBody>
@@ -8955,7 +8904,12 @@
           <a:lstStyle/>
           <a:p>
             <a:r>
-              <a:t>Next → Lesson 1.3: Logistic Regression</a:t>
+              <a:t>Limitations &amp;</a:t>
+            </a:r>
+          </a:p>
+          <a:p>
+            <a:r>
+              <a:t>Workshop</a:t>
             </a:r>
           </a:p>
         </p:txBody>
@@ -8967,7 +8921,7 @@
             <a:spLocks noGrp="1"/>
           </p:cNvSpPr>
           <p:nvPr>
-            <p:ph type="body" idx="14" sz="quarter"/>
+            <p:ph type="body" idx="16" sz="quarter"/>
           </p:nvPr>
         </p:nvSpPr>
         <p:spPr/>
@@ -8976,7 +8930,261 @@
           <a:lstStyle/>
           <a:p>
             <a:r>
-              <a:t>Linear Regression</a:t>
+              <a:t>06</a:t>
+            </a:r>
+          </a:p>
+        </p:txBody>
+      </p:sp>
+    </p:spTree>
+  </p:cSld>
+  <p:clrMapOvr>
+    <a:masterClrMapping/>
+  </p:clrMapOvr>
+</p:sld>
+</file>
+
+<file path=ppt/slides/slide17.xml><?xml version="1.0" encoding="utf-8"?>
+<p:sld xmlns:a="http://schemas.openxmlformats.org/drawingml/2006/main" xmlns:p="http://schemas.openxmlformats.org/presentationml/2006/main" xmlns:r="http://schemas.openxmlformats.org/officeDocument/2006/relationships">
+  <p:cSld>
+    <p:spTree>
+      <p:nvGrpSpPr>
+        <p:cNvPr id="1" name=""/>
+        <p:cNvGrpSpPr/>
+        <p:nvPr/>
+      </p:nvGrpSpPr>
+      <p:grpSpPr/>
+      <p:sp>
+        <p:nvSpPr>
+          <p:cNvPr id="2" name="Title 1"/>
+          <p:cNvSpPr>
+            <a:spLocks noGrp="1"/>
+          </p:cNvSpPr>
+          <p:nvPr>
+            <p:ph type="title"/>
+          </p:nvPr>
+        </p:nvSpPr>
+        <p:spPr/>
+        <p:txBody>
+          <a:bodyPr/>
+          <a:lstStyle/>
+          <a:p>
+            <a:r>
+              <a:t>Limitation — Real Servers Are Non-Linear</a:t>
+            </a:r>
+          </a:p>
+        </p:txBody>
+      </p:sp>
+      <p:pic>
+        <p:nvPicPr>
+          <p:cNvPr id="3" name="Picture 2" descr="lr_limitation.png"/>
+          <p:cNvPicPr>
+            <a:picLocks noChangeAspect="1"/>
+          </p:cNvPicPr>
+          <p:nvPr/>
+        </p:nvPicPr>
+        <p:blipFill>
+          <a:blip r:embed="rId2"/>
+          <a:stretch>
+            <a:fillRect/>
+          </a:stretch>
+        </p:blipFill>
+        <p:spPr>
+          <a:xfrm>
+            <a:off x="2011680" y="1371600"/>
+            <a:ext cx="8229600" cy="4780429"/>
+          </a:xfrm>
+          <a:prstGeom prst="rect">
+            <a:avLst/>
+          </a:prstGeom>
+        </p:spPr>
+      </p:pic>
+    </p:spTree>
+  </p:cSld>
+  <p:clrMapOvr>
+    <a:masterClrMapping/>
+  </p:clrMapOvr>
+</p:sld>
+</file>
+
+<file path=ppt/slides/slide18.xml><?xml version="1.0" encoding="utf-8"?>
+<p:sld xmlns:a="http://schemas.openxmlformats.org/drawingml/2006/main" xmlns:p="http://schemas.openxmlformats.org/presentationml/2006/main" xmlns:r="http://schemas.openxmlformats.org/officeDocument/2006/relationships">
+  <p:cSld>
+    <p:spTree>
+      <p:nvGrpSpPr>
+        <p:cNvPr id="1" name=""/>
+        <p:cNvGrpSpPr/>
+        <p:nvPr/>
+      </p:nvGrpSpPr>
+      <p:grpSpPr/>
+      <p:sp>
+        <p:nvSpPr>
+          <p:cNvPr id="2" name="Title 1"/>
+          <p:cNvSpPr>
+            <a:spLocks noGrp="1"/>
+          </p:cNvSpPr>
+          <p:nvPr>
+            <p:ph type="title"/>
+          </p:nvPr>
+        </p:nvSpPr>
+        <p:spPr/>
+        <p:txBody>
+          <a:bodyPr/>
+          <a:lstStyle/>
+          <a:p>
+            <a:r>
+              <a:t>Workshop — 4 Exercises</a:t>
+            </a:r>
+          </a:p>
+        </p:txBody>
+      </p:sp>
+      <p:sp>
+        <p:nvSpPr>
+          <p:cNvPr id="3" name="Content Placeholder 2"/>
+          <p:cNvSpPr>
+            <a:spLocks noGrp="1"/>
+          </p:cNvSpPr>
+          <p:nvPr>
+            <p:ph idx="1"/>
+          </p:nvPr>
+        </p:nvSpPr>
+        <p:spPr/>
+        <p:txBody>
+          <a:bodyPr/>
+          <a:lstStyle/>
+          <a:p>
+            <a:pPr/>
+            <a:r>
+              <a:t>Exercise 1: Understanding regression — the dataset, visualising the relationship</a:t>
+            </a:r>
+          </a:p>
+          <a:p>
+            <a:pPr/>
+            <a:r>
+              <a:t>Exercise 2: Train/test split — why we split, the danger of evaluating on training data</a:t>
+            </a:r>
+          </a:p>
+          <a:p>
+            <a:pPr/>
+            <a:r>
+              <a:t>Exercise 3: Fit and predict — model.fit(), slope/intercept, visualise the line</a:t>
+            </a:r>
+          </a:p>
+          <a:p>
+            <a:pPr/>
+            <a:r>
+              <a:t>Exercise 4: Evaluate — MSE, RMSE, MAE, R², build a security baseline</a:t>
+            </a:r>
+          </a:p>
+          <a:p>
+            <a:pPr/>
+          </a:p>
+          <a:p>
+            <a:pPr/>
+            <a:r>
+              <a:t>Each exercise: lecture.md → handson.md → solution_linear_regression.py</a:t>
+            </a:r>
+          </a:p>
+          <a:p>
+            <a:pPr/>
+            <a:r>
+              <a:t>Run your script after each step — verify output before moving on</a:t>
+            </a:r>
+          </a:p>
+        </p:txBody>
+      </p:sp>
+    </p:spTree>
+  </p:cSld>
+  <p:clrMapOvr>
+    <a:masterClrMapping/>
+  </p:clrMapOvr>
+</p:sld>
+</file>
+
+<file path=ppt/slides/slide19.xml><?xml version="1.0" encoding="utf-8"?>
+<p:sld xmlns:a="http://schemas.openxmlformats.org/drawingml/2006/main" xmlns:p="http://schemas.openxmlformats.org/presentationml/2006/main" xmlns:r="http://schemas.openxmlformats.org/officeDocument/2006/relationships">
+  <p:cSld>
+    <p:spTree>
+      <p:nvGrpSpPr>
+        <p:cNvPr id="1" name=""/>
+        <p:cNvGrpSpPr/>
+        <p:nvPr/>
+      </p:nvGrpSpPr>
+      <p:grpSpPr/>
+      <p:sp>
+        <p:nvSpPr>
+          <p:cNvPr id="2" name="Text Placeholder 1"/>
+          <p:cNvSpPr>
+            <a:spLocks noGrp="1"/>
+          </p:cNvSpPr>
+          <p:nvPr>
+            <p:ph type="body" idx="12" sz="quarter"/>
+          </p:nvPr>
+        </p:nvSpPr>
+        <p:spPr/>
+        <p:txBody>
+          <a:bodyPr/>
+          <a:lstStyle/>
+          <a:p>
+            <a:pPr/>
+            <a:r>
+              <a:t>Linear regression predicts a continuous value: y = weight × x + bias</a:t>
+            </a:r>
+          </a:p>
+          <a:p>
+            <a:pPr/>
+            <a:r>
+              <a:t>The model learns weight and bias by minimising prediction error</a:t>
+            </a:r>
+          </a:p>
+          <a:p>
+            <a:pPr/>
+            <a:r>
+              <a:t>R² measures fit quality; RMSE measures average error in real units</a:t>
+            </a:r>
+          </a:p>
+          <a:p>
+            <a:pPr/>
+            <a:r>
+              <a:t>Always split data into train/test before fitting</a:t>
+            </a:r>
+          </a:p>
+          <a:p>
+            <a:pPr/>
+            <a:r>
+              <a:t>Security use: build a baseline, flag anomalies when actual &gt;&gt; predicted</a:t>
+            </a:r>
+          </a:p>
+          <a:p>
+            <a:pPr/>
+            <a:r>
+              <a:t>Limitation: only captures linear relationships — neural networks handle the rest</a:t>
+            </a:r>
+          </a:p>
+          <a:p>
+            <a:pPr/>
+            <a:r>
+              <a:t>Next: Lesson 1.3 — Logistic Regression (binary classification)</a:t>
+            </a:r>
+          </a:p>
+        </p:txBody>
+      </p:sp>
+      <p:sp>
+        <p:nvSpPr>
+          <p:cNvPr id="3" name="Title 2"/>
+          <p:cNvSpPr>
+            <a:spLocks noGrp="1"/>
+          </p:cNvSpPr>
+          <p:nvPr>
+            <p:ph type="title"/>
+          </p:nvPr>
+        </p:nvSpPr>
+        <p:spPr/>
+        <p:txBody>
+          <a:bodyPr/>
+          <a:lstStyle/>
+          <a:p>
+            <a:r>
+              <a:t>Summary</a:t>
             </a:r>
           </a:p>
         </p:txBody>
@@ -9022,31 +9230,37 @@
           <a:p>
             <a:pPr/>
             <a:r>
+              <a:t>The equation: y = weight × x + bias</a:t>
+            </a:r>
+          </a:p>
+          <a:p>
+            <a:pPr/>
+            <a:r>
               <a:t>Real-life example: server response time</a:t>
             </a:r>
           </a:p>
           <a:p>
             <a:pPr/>
             <a:r>
-              <a:t>The equation: y = weight * x + bias</a:t>
+              <a:t>Train/test split and model fitting</a:t>
             </a:r>
           </a:p>
           <a:p>
             <a:pPr/>
             <a:r>
-              <a:t>Train/test split and model fitting</a:t>
+              <a:t>Evaluation: R², RMSE, MAE</a:t>
             </a:r>
           </a:p>
           <a:p>
             <a:pPr/>
             <a:r>
-              <a:t>Evaluation: R², RMSE, MAE</a:t>
+              <a:t>Security application: DoS anomaly detection</a:t>
             </a:r>
           </a:p>
           <a:p>
             <a:pPr/>
             <a:r>
-              <a:t>Security application: DoS anomaly detection</a:t>
+              <a:t>Limitations of linear models</a:t>
             </a:r>
           </a:p>
           <a:p>
@@ -9074,6 +9288,66 @@
           <a:p>
             <a:r>
               <a:t>Agenda</a:t>
+            </a:r>
+          </a:p>
+        </p:txBody>
+      </p:sp>
+    </p:spTree>
+  </p:cSld>
+  <p:clrMapOvr>
+    <a:masterClrMapping/>
+  </p:clrMapOvr>
+</p:sld>
+</file>
+
+<file path=ppt/slides/slide20.xml><?xml version="1.0" encoding="utf-8"?>
+<p:sld xmlns:a="http://schemas.openxmlformats.org/drawingml/2006/main" xmlns:p="http://schemas.openxmlformats.org/presentationml/2006/main" xmlns:r="http://schemas.openxmlformats.org/officeDocument/2006/relationships">
+  <p:cSld>
+    <p:spTree>
+      <p:nvGrpSpPr>
+        <p:cNvPr id="1" name=""/>
+        <p:cNvGrpSpPr/>
+        <p:nvPr/>
+      </p:nvGrpSpPr>
+      <p:grpSpPr/>
+      <p:sp>
+        <p:nvSpPr>
+          <p:cNvPr id="2" name="Text Placeholder 1"/>
+          <p:cNvSpPr>
+            <a:spLocks noGrp="1"/>
+          </p:cNvSpPr>
+          <p:nvPr>
+            <p:ph type="body" idx="13" sz="quarter"/>
+          </p:nvPr>
+        </p:nvSpPr>
+        <p:spPr/>
+        <p:txBody>
+          <a:bodyPr/>
+          <a:lstStyle/>
+          <a:p>
+            <a:r>
+              <a:t>Next → Lesson 1.3: Logistic Regression</a:t>
+            </a:r>
+          </a:p>
+        </p:txBody>
+      </p:sp>
+      <p:sp>
+        <p:nvSpPr>
+          <p:cNvPr id="3" name="Text Placeholder 2"/>
+          <p:cNvSpPr>
+            <a:spLocks noGrp="1"/>
+          </p:cNvSpPr>
+          <p:nvPr>
+            <p:ph type="body" idx="14" sz="quarter"/>
+          </p:nvPr>
+        </p:nvSpPr>
+        <p:spPr/>
+        <p:txBody>
+          <a:bodyPr/>
+          <a:lstStyle/>
+          <a:p>
+            <a:r>
+              <a:t>Linear Regression</a:t>
             </a:r>
           </a:p>
         </p:txBody>
@@ -9112,7 +9386,12 @@
           <a:lstStyle/>
           <a:p>
             <a:r>
-              <a:t>Predicting a Number</a:t>
+              <a:t>Predicting</a:t>
+            </a:r>
+          </a:p>
+          <a:p>
+            <a:r>
+              <a:t>a Number</a:t>
             </a:r>
           </a:p>
         </p:txBody>
@@ -9184,7 +9463,7 @@
             <a:spLocks noGrp="1"/>
           </p:cNvSpPr>
           <p:nvPr>
-            <p:ph idx="1"/>
+            <p:ph idx="2" sz="half"/>
           </p:nvPr>
         </p:nvSpPr>
         <p:spPr/>
@@ -9194,43 +9473,101 @@
           <a:p>
             <a:pPr/>
             <a:r>
-              <a:t>Classification (Lesson 1.3): predict a category — phishing or legitimate</a:t>
+              <a:t>Regression</a:t>
             </a:r>
           </a:p>
           <a:p>
             <a:pPr/>
-            <a:r>
-              <a:t>Regression: predict a continuous number — response time in milliseconds</a:t>
-            </a:r>
           </a:p>
           <a:p>
             <a:pPr/>
             <a:r>
-              <a:t>Linear regression fits a straight line through your data:</a:t>
+              <a:t>Predicts a continuous number</a:t>
             </a:r>
           </a:p>
           <a:p>
             <a:pPr lvl="1"/>
             <a:r>
-              <a:t>y = (weight × x) + bias</a:t>
+              <a:t>How many milliseconds?</a:t>
             </a:r>
           </a:p>
           <a:p>
             <a:pPr lvl="1"/>
             <a:r>
-              <a:t>weight — how many ms per extra request/second</a:t>
+              <a:t>How many bytes?</a:t>
             </a:r>
           </a:p>
           <a:p>
             <a:pPr lvl="1"/>
             <a:r>
-              <a:t>bias — baseline ms when traffic = 0</a:t>
+              <a:t>What temperature?</a:t>
             </a:r>
           </a:p>
           <a:p>
             <a:pPr/>
-            <a:r>
-              <a:t>The model learns the best weight and bias to minimise error</a:t>
+          </a:p>
+          <a:p>
+            <a:pPr/>
+            <a:r>
+              <a:t>Output: 142.7 ms</a:t>
+            </a:r>
+          </a:p>
+        </p:txBody>
+      </p:sp>
+      <p:sp>
+        <p:nvSpPr>
+          <p:cNvPr id="4" name="Content Placeholder 3"/>
+          <p:cNvSpPr>
+            <a:spLocks noGrp="1"/>
+          </p:cNvSpPr>
+          <p:nvPr>
+            <p:ph idx="12" sz="half"/>
+          </p:nvPr>
+        </p:nvSpPr>
+        <p:spPr/>
+        <p:txBody>
+          <a:bodyPr/>
+          <a:lstStyle/>
+          <a:p>
+            <a:pPr/>
+            <a:r>
+              <a:t>Classification (Lesson 1.3)</a:t>
+            </a:r>
+          </a:p>
+          <a:p>
+            <a:pPr/>
+          </a:p>
+          <a:p>
+            <a:pPr/>
+            <a:r>
+              <a:t>Predicts a category</a:t>
+            </a:r>
+          </a:p>
+          <a:p>
+            <a:pPr lvl="1"/>
+            <a:r>
+              <a:t>Phishing or legitimate?</a:t>
+            </a:r>
+          </a:p>
+          <a:p>
+            <a:pPr lvl="1"/>
+            <a:r>
+              <a:t>Malware or benign?</a:t>
+            </a:r>
+          </a:p>
+          <a:p>
+            <a:pPr lvl="1"/>
+            <a:r>
+              <a:t>Attack or normal?</a:t>
+            </a:r>
+          </a:p>
+          <a:p>
+            <a:pPr/>
+          </a:p>
+          <a:p>
+            <a:pPr/>
+            <a:r>
+              <a:t>Output: phishing (87%)</a:t>
             </a:r>
           </a:p>
         </p:txBody>
@@ -9269,69 +9606,35 @@
           <a:lstStyle/>
           <a:p>
             <a:r>
-              <a:t>Real-Life Example: Server Response Time</a:t>
-            </a:r>
-          </a:p>
-        </p:txBody>
-      </p:sp>
-      <p:sp>
-        <p:nvSpPr>
-          <p:cNvPr id="3" name="Content Placeholder 2"/>
-          <p:cNvSpPr>
-            <a:spLocks noGrp="1"/>
-          </p:cNvSpPr>
-          <p:nvPr>
-            <p:ph idx="1"/>
-          </p:nvPr>
-        </p:nvSpPr>
-        <p:spPr/>
-        <p:txBody>
-          <a:bodyPr/>
-          <a:lstStyle/>
-          <a:p>
-            <a:pPr/>
-            <a:r>
-              <a:t>Scenario: monitoring a web server under varying traffic load</a:t>
-            </a:r>
-          </a:p>
-          <a:p>
-            <a:pPr/>
-            <a:r>
-              <a:t>As requests/second increases, response time goes up</a:t>
-            </a:r>
-          </a:p>
-          <a:p>
-            <a:pPr/>
-            <a:r>
-              <a:t>Can we predict response time from traffic?</a:t>
-            </a:r>
-          </a:p>
-          <a:p>
-            <a:pPr/>
-            <a:r>
-              <a:t>Why this matters for security:</a:t>
-            </a:r>
-          </a:p>
-          <a:p>
-            <a:pPr lvl="1"/>
-            <a:r>
-              <a:t>Build a 'normal behaviour' baseline</a:t>
-            </a:r>
-          </a:p>
-          <a:p>
-            <a:pPr lvl="1"/>
-            <a:r>
-              <a:t>Predicted = 120ms but actual = 4000ms → possible DoS attack</a:t>
-            </a:r>
-          </a:p>
-          <a:p>
-            <a:pPr lvl="1"/>
-            <a:r>
-              <a:t>This is the foundation of anomaly detection</a:t>
-            </a:r>
-          </a:p>
-        </p:txBody>
-      </p:sp>
+              <a:t>The Equation Behind Linear Regression</a:t>
+            </a:r>
+          </a:p>
+        </p:txBody>
+      </p:sp>
+      <p:pic>
+        <p:nvPicPr>
+          <p:cNvPr id="3" name="Picture 2" descr="lr_equation.png"/>
+          <p:cNvPicPr>
+            <a:picLocks noChangeAspect="1"/>
+          </p:cNvPicPr>
+          <p:nvPr/>
+        </p:nvPicPr>
+        <p:blipFill>
+          <a:blip r:embed="rId2"/>
+          <a:stretch>
+            <a:fillRect/>
+          </a:stretch>
+        </p:blipFill>
+        <p:spPr>
+          <a:xfrm>
+            <a:off x="1371600" y="1645920"/>
+            <a:ext cx="9418320" cy="2569875"/>
+          </a:xfrm>
+          <a:prstGeom prst="rect">
+            <a:avLst/>
+          </a:prstGeom>
+        </p:spPr>
+      </p:pic>
     </p:spTree>
   </p:cSld>
   <p:clrMapOvr>
@@ -9366,7 +9669,12 @@
           <a:lstStyle/>
           <a:p>
             <a:r>
-              <a:t>Training the Model</a:t>
+              <a:t>Server Response</a:t>
+            </a:r>
+          </a:p>
+          <a:p>
+            <a:r>
+              <a:t>Time</a:t>
             </a:r>
           </a:p>
         </p:txBody>
@@ -9426,69 +9734,35 @@
           <a:lstStyle/>
           <a:p>
             <a:r>
-              <a:t>Train / Test Split</a:t>
-            </a:r>
-          </a:p>
-        </p:txBody>
-      </p:sp>
-      <p:sp>
-        <p:nvSpPr>
-          <p:cNvPr id="3" name="Content Placeholder 2"/>
-          <p:cNvSpPr>
-            <a:spLocks noGrp="1"/>
-          </p:cNvSpPr>
-          <p:nvPr>
-            <p:ph idx="1"/>
-          </p:nvPr>
-        </p:nvSpPr>
-        <p:spPr/>
-        <p:txBody>
-          <a:bodyPr/>
-          <a:lstStyle/>
-          <a:p>
-            <a:pPr/>
-            <a:r>
-              <a:t>Split your data before training — never evaluate on training data</a:t>
-            </a:r>
-          </a:p>
-          <a:p>
-            <a:pPr/>
-            <a:r>
-              <a:t>train_test_split(X, y, test_size=0.2, random_state=42)</a:t>
-            </a:r>
-          </a:p>
-          <a:p>
-            <a:pPr lvl="1"/>
-            <a:r>
-              <a:t>80% of data → training set (model learns from this)</a:t>
-            </a:r>
-          </a:p>
-          <a:p>
-            <a:pPr lvl="1"/>
-            <a:r>
-              <a:t>20% of data → test set (model is evaluated on this)</a:t>
-            </a:r>
-          </a:p>
-          <a:p>
-            <a:pPr/>
-            <a:r>
-              <a:t>Why?</a:t>
-            </a:r>
-          </a:p>
-          <a:p>
-            <a:pPr lvl="1"/>
-            <a:r>
-              <a:t>Evaluating on training data measures memorisation, not generalisation</a:t>
-            </a:r>
-          </a:p>
-          <a:p>
-            <a:pPr lvl="1"/>
-            <a:r>
-              <a:t>The test set gives an honest estimate of real-world performance</a:t>
-            </a:r>
-          </a:p>
-        </p:txBody>
-      </p:sp>
+              <a:t>Fitting a Line Through Server Performance Data</a:t>
+            </a:r>
+          </a:p>
+        </p:txBody>
+      </p:sp>
+      <p:pic>
+        <p:nvPicPr>
+          <p:cNvPr id="3" name="Picture 2" descr="lr_scatter.png"/>
+          <p:cNvPicPr>
+            <a:picLocks noChangeAspect="1"/>
+          </p:cNvPicPr>
+          <p:nvPr/>
+        </p:nvPicPr>
+        <p:blipFill>
+          <a:blip r:embed="rId2"/>
+          <a:stretch>
+            <a:fillRect/>
+          </a:stretch>
+        </p:blipFill>
+        <p:spPr>
+          <a:xfrm>
+            <a:off x="2011680" y="1371600"/>
+            <a:ext cx="8229600" cy="5026843"/>
+          </a:xfrm>
+          <a:prstGeom prst="rect">
+            <a:avLst/>
+          </a:prstGeom>
+        </p:spPr>
+      </p:pic>
     </p:spTree>
   </p:cSld>
   <p:clrMapOvr>
@@ -9509,7 +9783,65 @@
       <p:grpSpPr/>
       <p:sp>
         <p:nvSpPr>
-          <p:cNvPr id="2" name="Title 1"/>
+          <p:cNvPr id="2" name="Text Placeholder 1"/>
+          <p:cNvSpPr>
+            <a:spLocks noGrp="1"/>
+          </p:cNvSpPr>
+          <p:nvPr>
+            <p:ph type="body" idx="14" sz="quarter"/>
+          </p:nvPr>
+        </p:nvSpPr>
+        <p:spPr/>
+        <p:txBody>
+          <a:bodyPr/>
+          <a:lstStyle/>
+          <a:p>
+            <a:r>
+              <a:t>— Anomaly detection in action</a:t>
+            </a:r>
+          </a:p>
+        </p:txBody>
+      </p:sp>
+      <p:sp>
+        <p:nvSpPr>
+          <p:cNvPr id="3" name="Text Placeholder 2"/>
+          <p:cNvSpPr>
+            <a:spLocks noGrp="1"/>
+          </p:cNvSpPr>
+          <p:nvPr>
+            <p:ph type="body" idx="15" sz="quarter"/>
+          </p:nvPr>
+        </p:nvSpPr>
+        <p:spPr/>
+        <p:txBody>
+          <a:bodyPr/>
+          <a:lstStyle/>
+          <a:p>
+            <a:r>
+              <a:t>Predicted = 120ms</a:t>
+            </a:r>
+          </a:p>
+          <a:p>
+            <a:r>
+              <a:t>Actual = 4,000ms</a:t>
+            </a:r>
+          </a:p>
+          <a:p/>
+          <a:p>
+            <a:r>
+              <a:t>→ Possible DoS attack</a:t>
+            </a:r>
+          </a:p>
+          <a:p>
+            <a:r>
+              <a:t>or resource exhaustion</a:t>
+            </a:r>
+          </a:p>
+        </p:txBody>
+      </p:sp>
+      <p:sp>
+        <p:nvSpPr>
+          <p:cNvPr id="4" name="Title 3"/>
           <p:cNvSpPr>
             <a:spLocks noGrp="1"/>
           </p:cNvSpPr>
@@ -9523,19 +9855,19 @@
           <a:lstStyle/>
           <a:p>
             <a:r>
-              <a:t>Fitting and Predicting</a:t>
-            </a:r>
-          </a:p>
-        </p:txBody>
-      </p:sp>
-      <p:sp>
-        <p:nvSpPr>
-          <p:cNvPr id="3" name="Content Placeholder 2"/>
+              <a:t>Why This Matters for Security</a:t>
+            </a:r>
+          </a:p>
+        </p:txBody>
+      </p:sp>
+      <p:sp>
+        <p:nvSpPr>
+          <p:cNvPr id="5" name="Text Placeholder 4"/>
           <p:cNvSpPr>
             <a:spLocks noGrp="1"/>
           </p:cNvSpPr>
           <p:nvPr>
-            <p:ph idx="1"/>
+            <p:ph type="body" idx="16" sz="quarter"/>
           </p:nvPr>
         </p:nvSpPr>
         <p:spPr/>
@@ -9545,43 +9877,31 @@
           <a:p>
             <a:pPr/>
             <a:r>
-              <a:t>model = LinearRegression()</a:t>
+              <a:t>Monitoring a web server under load</a:t>
             </a:r>
           </a:p>
           <a:p>
             <a:pPr/>
             <a:r>
-              <a:t>model.fit(X_train, y_train)   — learn the line from training data</a:t>
+              <a:t>As traffic increases, response time goes up</a:t>
             </a:r>
           </a:p>
           <a:p>
             <a:pPr/>
             <a:r>
-              <a:t>y_pred = model.predict(X_test)   — predict on unseen data</a:t>
+              <a:t>The model learns the normal relationship</a:t>
             </a:r>
           </a:p>
           <a:p>
             <a:pPr/>
             <a:r>
-              <a:t>After fitting, inspect what the model learned:</a:t>
+              <a:t>Then compares actual vs predicted:</a:t>
             </a:r>
           </a:p>
           <a:p>
             <a:pPr lvl="1"/>
             <a:r>
-              <a:t>model.coef_   — the slope (ms per req/s)</a:t>
-            </a:r>
-          </a:p>
-          <a:p>
-            <a:pPr lvl="1"/>
-            <a:r>
-              <a:t>model.intercept_   — baseline response time</a:t>
-            </a:r>
-          </a:p>
-          <a:p>
-            <a:pPr/>
-            <a:r>
-              <a:t>These numbers have direct physical meaning</a:t>
+              <a:t>Large gap = something is wrong</a:t>
             </a:r>
           </a:p>
         </p:txBody>
@@ -9620,7 +9940,12 @@
           <a:lstStyle/>
           <a:p>
             <a:r>
-              <a:t>Evaluating the Model</a:t>
+              <a:t>Training</a:t>
+            </a:r>
+          </a:p>
+          <a:p>
+            <a:r>
+              <a:t>the Model</a:t>
             </a:r>
           </a:p>
         </p:txBody>

</xml_diff>

<commit_message>
Rebuild Stage 1 lectures 2-5 with professional structure and visuals
Each lecture reorganised with 5 focused sections (down from 5-6
fragmented dividers), consistent colour palette, professional
matplotlib-generated images, and varied template layouts. Tighter
content with one idea per slide and clear narrative flow.

- Lecture 2 (21 slides): regression equation, scatter plots, metrics cards, anomaly baseline
- Lecture 3 (20 slides): sigmoid curve, URL features, coefficients, threshold tuning
- Lecture 4 (20 slides): tree flowchart, Gini pies, attack signatures, overfitting chart
- Lecture 5 (22 slides): accuracy trap, confusion matrix, metric cards, ROC curve, PR tradeoff
</commit_message>
<xml_diff>
--- a/stage1_classic_ml/02_linear_regression/Lecture-2-Linear-Regression.pptx
+++ b/stage1_classic_ml/02_linear_regression/Lecture-2-Linear-Regression.pptx
@@ -31,6 +31,7 @@
     <p:sldId id="273" r:id="rId29"/>
     <p:sldId id="274" r:id="rId30"/>
     <p:sldId id="275" r:id="rId31"/>
+    <p:sldId id="276" r:id="rId32"/>
   </p:sldIdLst>
   <p:sldSz cx="12188825" cy="6858000"/>
   <p:notesSz cx="7010400" cy="9296400"/>
@@ -8334,7 +8335,7 @@
           <a:lstStyle/>
           <a:p>
             <a:r>
-              <a:t>Lesson 1.2 — Stage 1: Classic Machine Learning</a:t>
+              <a:t>Lesson 1.2  |  Stage 1: Classic Machine Learning</a:t>
             </a:r>
           </a:p>
         </p:txBody>
@@ -8376,7 +8377,7 @@
           <a:lstStyle/>
           <a:p>
             <a:r>
-              <a:t>For Security Professionals</a:t>
+              <a:t>Your First Trained Model  -  Predicting Server Response Time</a:t>
             </a:r>
           </a:p>
         </p:txBody>
@@ -8401,12 +8402,12 @@
       <p:grpSpPr/>
       <p:sp>
         <p:nvSpPr>
-          <p:cNvPr id="2" name="Title 1"/>
+          <p:cNvPr id="2" name="Text Placeholder 1"/>
           <p:cNvSpPr>
             <a:spLocks noGrp="1"/>
           </p:cNvSpPr>
           <p:nvPr>
-            <p:ph type="title"/>
+            <p:ph type="body" idx="13" sz="quarter"/>
           </p:nvPr>
         </p:nvSpPr>
         <p:spPr/>
@@ -8415,19 +8416,24 @@
           <a:lstStyle/>
           <a:p>
             <a:r>
-              <a:t>Fitting and Predicting — The sklearn API</a:t>
-            </a:r>
-          </a:p>
-        </p:txBody>
-      </p:sp>
-      <p:sp>
-        <p:nvSpPr>
-          <p:cNvPr id="3" name="Content Placeholder 2"/>
+              <a:t>Fitting the Model</a:t>
+            </a:r>
+          </a:p>
+          <a:p>
+            <a:r>
+              <a:t>and Measuring Results</a:t>
+            </a:r>
+          </a:p>
+        </p:txBody>
+      </p:sp>
+      <p:sp>
+        <p:nvSpPr>
+          <p:cNvPr id="3" name="Text Placeholder 2"/>
           <p:cNvSpPr>
             <a:spLocks noGrp="1"/>
           </p:cNvSpPr>
           <p:nvPr>
-            <p:ph idx="1"/>
+            <p:ph type="body" idx="16" sz="quarter"/>
           </p:nvPr>
         </p:nvSpPr>
         <p:spPr/>
@@ -8435,63 +8441,8 @@
           <a:bodyPr/>
           <a:lstStyle/>
           <a:p>
-            <a:pPr/>
-            <a:r>
-              <a:t>Split first — never evaluate on training data:</a:t>
-            </a:r>
-          </a:p>
-          <a:p>
-            <a:pPr lvl="1"/>
-            <a:r>
-              <a:t>X_train, X_test, y_train, y_test = train_test_split(X, y, test_size=0.2)</a:t>
-            </a:r>
-          </a:p>
-          <a:p>
-            <a:pPr/>
-          </a:p>
-          <a:p>
-            <a:pPr/>
-            <a:r>
-              <a:t>Then fit and predict:</a:t>
-            </a:r>
-          </a:p>
-          <a:p>
-            <a:pPr lvl="1"/>
-            <a:r>
-              <a:t>model = LinearRegression()</a:t>
-            </a:r>
-          </a:p>
-          <a:p>
-            <a:pPr lvl="1"/>
-            <a:r>
-              <a:t>model.fit(X_train, y_train)     — learn the line</a:t>
-            </a:r>
-          </a:p>
-          <a:p>
-            <a:pPr lvl="1"/>
-            <a:r>
-              <a:t>y_pred = model.predict(X_test)  — predict on unseen data</a:t>
-            </a:r>
-          </a:p>
-          <a:p>
-            <a:pPr/>
-          </a:p>
-          <a:p>
-            <a:pPr/>
-            <a:r>
-              <a:t>Inspect what the model learned:</a:t>
-            </a:r>
-          </a:p>
-          <a:p>
-            <a:pPr lvl="1"/>
-            <a:r>
-              <a:t>model.coef_       — the slope (ms per req/s)</a:t>
-            </a:r>
-          </a:p>
-          <a:p>
-            <a:pPr lvl="1"/>
-            <a:r>
-              <a:t>model.intercept_  — baseline response time</a:t>
+            <a:r>
+              <a:t>03</a:t>
             </a:r>
           </a:p>
         </p:txBody>
@@ -8516,12 +8467,12 @@
       <p:grpSpPr/>
       <p:sp>
         <p:nvSpPr>
-          <p:cNvPr id="2" name="Text Placeholder 1"/>
+          <p:cNvPr id="2" name="Title 1"/>
           <p:cNvSpPr>
             <a:spLocks noGrp="1"/>
           </p:cNvSpPr>
           <p:nvPr>
-            <p:ph type="body" idx="13" sz="quarter"/>
+            <p:ph type="title"/>
           </p:nvPr>
         </p:nvSpPr>
         <p:spPr/>
@@ -8530,37 +8481,35 @@
           <a:lstStyle/>
           <a:p>
             <a:r>
-              <a:t>Evaluating</a:t>
-            </a:r>
-          </a:p>
-          <a:p>
-            <a:r>
-              <a:t>the Model</a:t>
-            </a:r>
-          </a:p>
-        </p:txBody>
-      </p:sp>
-      <p:sp>
-        <p:nvSpPr>
-          <p:cNvPr id="3" name="Text Placeholder 2"/>
-          <p:cNvSpPr>
-            <a:spLocks noGrp="1"/>
-          </p:cNvSpPr>
-          <p:nvPr>
-            <p:ph type="body" idx="16" sz="quarter"/>
-          </p:nvPr>
-        </p:nvSpPr>
-        <p:spPr/>
-        <p:txBody>
-          <a:bodyPr/>
-          <a:lstStyle/>
-          <a:p>
-            <a:r>
-              <a:t>04</a:t>
-            </a:r>
-          </a:p>
-        </p:txBody>
-      </p:sp>
+              <a:t>The sklearn Pipeline - Five Steps</a:t>
+            </a:r>
+          </a:p>
+        </p:txBody>
+      </p:sp>
+      <p:pic>
+        <p:nvPicPr>
+          <p:cNvPr id="3" name="Picture 2" descr="api_flow.png"/>
+          <p:cNvPicPr>
+            <a:picLocks noChangeAspect="1"/>
+          </p:cNvPicPr>
+          <p:nvPr/>
+        </p:nvPicPr>
+        <p:blipFill>
+          <a:blip r:embed="rId2"/>
+          <a:stretch>
+            <a:fillRect/>
+          </a:stretch>
+        </p:blipFill>
+        <p:spPr>
+          <a:xfrm>
+            <a:off x="457200" y="1828800"/>
+            <a:ext cx="11247120" cy="3149194"/>
+          </a:xfrm>
+          <a:prstGeom prst="rect">
+            <a:avLst/>
+          </a:prstGeom>
+        </p:spPr>
+      </p:pic>
     </p:spTree>
   </p:cSld>
   <p:clrMapOvr>
@@ -8595,35 +8544,75 @@
           <a:lstStyle/>
           <a:p>
             <a:r>
-              <a:t>Regression Evaluation Metrics</a:t>
-            </a:r>
-          </a:p>
-        </p:txBody>
-      </p:sp>
-      <p:pic>
-        <p:nvPicPr>
-          <p:cNvPr id="3" name="Picture 2" descr="lr_metrics.png"/>
-          <p:cNvPicPr>
-            <a:picLocks noChangeAspect="1"/>
-          </p:cNvPicPr>
-          <p:nvPr/>
-        </p:nvPicPr>
-        <p:blipFill>
-          <a:blip r:embed="rId2"/>
-          <a:stretch>
-            <a:fillRect/>
-          </a:stretch>
-        </p:blipFill>
-        <p:spPr>
-          <a:xfrm>
-            <a:off x="1371600" y="1371600"/>
-            <a:ext cx="9418320" cy="4875087"/>
-          </a:xfrm>
-          <a:prstGeom prst="rect">
-            <a:avLst/>
-          </a:prstGeom>
-        </p:spPr>
-      </p:pic>
+              <a:t>The Code - Four Lines That Do Everything</a:t>
+            </a:r>
+          </a:p>
+        </p:txBody>
+      </p:sp>
+      <p:sp>
+        <p:nvSpPr>
+          <p:cNvPr id="3" name="Content Placeholder 2"/>
+          <p:cNvSpPr>
+            <a:spLocks noGrp="1"/>
+          </p:cNvSpPr>
+          <p:nvPr>
+            <p:ph idx="1"/>
+          </p:nvPr>
+        </p:nvSpPr>
+        <p:spPr/>
+        <p:txBody>
+          <a:bodyPr/>
+          <a:lstStyle/>
+          <a:p>
+            <a:r>
+              <a:rPr sz="1500"/>
+              <a:t>X_train, X_test, y_train, y_test = train_test_split(X, y, test_size=0.2)</a:t>
+            </a:r>
+          </a:p>
+          <a:p>
+            <a:r>
+              <a:rPr sz="1500"/>
+              <a:t/>
+            </a:r>
+          </a:p>
+          <a:p>
+            <a:r>
+              <a:rPr sz="1500"/>
+              <a:t>model = LinearRegression()</a:t>
+            </a:r>
+          </a:p>
+          <a:p>
+            <a:r>
+              <a:rPr sz="1500"/>
+              <a:t>model.fit(X_train, y_train)          # learn slope + intercept</a:t>
+            </a:r>
+          </a:p>
+          <a:p>
+            <a:r>
+              <a:rPr sz="1500"/>
+              <a:t>y_pred = model.predict(X_test)     # predict on unseen data</a:t>
+            </a:r>
+          </a:p>
+          <a:p>
+            <a:r>
+              <a:rPr sz="1500"/>
+              <a:t/>
+            </a:r>
+          </a:p>
+          <a:p>
+            <a:r>
+              <a:rPr sz="1500"/>
+              <a:t>print(model.coef_)          # the learned coefficient</a:t>
+            </a:r>
+          </a:p>
+          <a:p>
+            <a:r>
+              <a:rPr sz="1500"/>
+              <a:t>print(model.intercept_)   # the learned intercept</a:t>
+            </a:r>
+          </a:p>
+        </p:txBody>
+      </p:sp>
     </p:spTree>
   </p:cSld>
   <p:clrMapOvr>
@@ -8644,12 +8633,12 @@
       <p:grpSpPr/>
       <p:sp>
         <p:nvSpPr>
-          <p:cNvPr id="2" name="Text Placeholder 1"/>
+          <p:cNvPr id="2" name="Title 1"/>
           <p:cNvSpPr>
             <a:spLocks noGrp="1"/>
           </p:cNvSpPr>
           <p:nvPr>
-            <p:ph type="body" idx="13" sz="quarter"/>
+            <p:ph type="title"/>
           </p:nvPr>
         </p:nvSpPr>
         <p:spPr/>
@@ -8658,37 +8647,35 @@
           <a:lstStyle/>
           <a:p>
             <a:r>
-              <a:t>Security Application:</a:t>
-            </a:r>
-          </a:p>
-          <a:p>
-            <a:r>
-              <a:t>Anomaly Detection</a:t>
-            </a:r>
-          </a:p>
-        </p:txBody>
-      </p:sp>
-      <p:sp>
-        <p:nvSpPr>
-          <p:cNvPr id="3" name="Text Placeholder 2"/>
-          <p:cNvSpPr>
-            <a:spLocks noGrp="1"/>
-          </p:cNvSpPr>
-          <p:nvPr>
-            <p:ph type="body" idx="16" sz="quarter"/>
-          </p:nvPr>
-        </p:nvSpPr>
-        <p:spPr/>
-        <p:txBody>
-          <a:bodyPr/>
-          <a:lstStyle/>
-          <a:p>
-            <a:r>
-              <a:t>05</a:t>
-            </a:r>
-          </a:p>
-        </p:txBody>
-      </p:sp>
+              <a:t>Three Evaluation Metrics</a:t>
+            </a:r>
+          </a:p>
+        </p:txBody>
+      </p:sp>
+      <p:pic>
+        <p:nvPicPr>
+          <p:cNvPr id="3" name="Picture 2" descr="metrics.png"/>
+          <p:cNvPicPr>
+            <a:picLocks noChangeAspect="1"/>
+          </p:cNvPicPr>
+          <p:nvPr/>
+        </p:nvPicPr>
+        <p:blipFill>
+          <a:blip r:embed="rId2"/>
+          <a:stretch>
+            <a:fillRect/>
+          </a:stretch>
+        </p:blipFill>
+        <p:spPr>
+          <a:xfrm>
+            <a:off x="274320" y="1371600"/>
+            <a:ext cx="11612880" cy="3451116"/>
+          </a:xfrm>
+          <a:prstGeom prst="rect">
+            <a:avLst/>
+          </a:prstGeom>
+        </p:spPr>
+      </p:pic>
     </p:spTree>
   </p:cSld>
   <p:clrMapOvr>
@@ -8709,12 +8696,12 @@
       <p:grpSpPr/>
       <p:sp>
         <p:nvSpPr>
-          <p:cNvPr id="2" name="Title 1"/>
+          <p:cNvPr id="2" name="Text Placeholder 1"/>
           <p:cNvSpPr>
             <a:spLocks noGrp="1"/>
           </p:cNvSpPr>
           <p:nvPr>
-            <p:ph type="title"/>
+            <p:ph type="body" idx="13" sz="quarter"/>
           </p:nvPr>
         </p:nvSpPr>
         <p:spPr/>
@@ -8723,35 +8710,37 @@
           <a:lstStyle/>
           <a:p>
             <a:r>
-              <a:t>Building an Anomaly Baseline from the Regression Line</a:t>
-            </a:r>
-          </a:p>
-        </p:txBody>
-      </p:sp>
-      <p:pic>
-        <p:nvPicPr>
-          <p:cNvPr id="3" name="Picture 2" descr="lr_anomaly.png"/>
-          <p:cNvPicPr>
-            <a:picLocks noChangeAspect="1"/>
-          </p:cNvPicPr>
-          <p:nvPr/>
-        </p:nvPicPr>
-        <p:blipFill>
-          <a:blip r:embed="rId2"/>
-          <a:stretch>
-            <a:fillRect/>
-          </a:stretch>
-        </p:blipFill>
-        <p:spPr>
-          <a:xfrm>
-            <a:off x="1554480" y="1371600"/>
-            <a:ext cx="9144000" cy="5075241"/>
-          </a:xfrm>
-          <a:prstGeom prst="rect">
-            <a:avLst/>
-          </a:prstGeom>
-        </p:spPr>
-      </p:pic>
+              <a:t>Security Application:</a:t>
+            </a:r>
+          </a:p>
+          <a:p>
+            <a:r>
+              <a:t>Anomaly Detection</a:t>
+            </a:r>
+          </a:p>
+        </p:txBody>
+      </p:sp>
+      <p:sp>
+        <p:nvSpPr>
+          <p:cNvPr id="3" name="Text Placeholder 2"/>
+          <p:cNvSpPr>
+            <a:spLocks noGrp="1"/>
+          </p:cNvSpPr>
+          <p:nvPr>
+            <p:ph type="body" idx="16" sz="quarter"/>
+          </p:nvPr>
+        </p:nvSpPr>
+        <p:spPr/>
+        <p:txBody>
+          <a:bodyPr/>
+          <a:lstStyle/>
+          <a:p>
+            <a:r>
+              <a:t>04</a:t>
+            </a:r>
+          </a:p>
+        </p:txBody>
+      </p:sp>
     </p:spTree>
   </p:cSld>
   <p:clrMapOvr>
@@ -8786,90 +8775,35 @@
           <a:lstStyle/>
           <a:p>
             <a:r>
-              <a:t>How the Baseline Works</a:t>
-            </a:r>
-          </a:p>
-        </p:txBody>
-      </p:sp>
-      <p:sp>
-        <p:nvSpPr>
-          <p:cNvPr id="3" name="Content Placeholder 2"/>
-          <p:cNvSpPr>
-            <a:spLocks noGrp="1"/>
-          </p:cNvSpPr>
-          <p:nvPr>
-            <p:ph idx="1"/>
-          </p:nvPr>
-        </p:nvSpPr>
-        <p:spPr/>
-        <p:txBody>
-          <a:bodyPr/>
-          <a:lstStyle/>
-          <a:p>
-            <a:pPr/>
-            <a:r>
-              <a:t>Once trained, the model predicts 'expected' response time for any traffic level</a:t>
-            </a:r>
-          </a:p>
-          <a:p>
-            <a:pPr/>
-            <a:r>
-              <a:t>Compare actual vs predicted:</a:t>
-            </a:r>
-          </a:p>
-          <a:p>
-            <a:pPr lvl="1"/>
-            <a:r>
-              <a:t>residual = actual − predicted</a:t>
-            </a:r>
-          </a:p>
-          <a:p>
-            <a:pPr lvl="1"/>
-            <a:r>
-              <a:t>Small residual → normal behaviour</a:t>
-            </a:r>
-          </a:p>
-          <a:p>
-            <a:pPr lvl="1"/>
-            <a:r>
-              <a:t>Large positive residual → server slower than expected → investigate</a:t>
-            </a:r>
-          </a:p>
-          <a:p>
-            <a:pPr/>
-          </a:p>
-          <a:p>
-            <a:pPr/>
-            <a:r>
-              <a:t>Possible causes flagged by anomaly:</a:t>
-            </a:r>
-          </a:p>
-          <a:p>
-            <a:pPr lvl="1"/>
-            <a:r>
-              <a:t>DoS attack saturating resources</a:t>
-            </a:r>
-          </a:p>
-          <a:p>
-            <a:pPr lvl="1"/>
-            <a:r>
-              <a:t>Crypto mining consuming CPU</a:t>
-            </a:r>
-          </a:p>
-          <a:p>
-            <a:pPr lvl="1"/>
-            <a:r>
-              <a:t>Runaway process or memory leak</a:t>
-            </a:r>
-          </a:p>
-          <a:p>
-            <a:pPr/>
-            <a:r>
-              <a:t>This simple technique powers many production anomaly detectors</a:t>
-            </a:r>
-          </a:p>
-        </p:txBody>
-      </p:sp>
+              <a:t>Using the Regression Line as an Anomaly Baseline</a:t>
+            </a:r>
+          </a:p>
+        </p:txBody>
+      </p:sp>
+      <p:pic>
+        <p:nvPicPr>
+          <p:cNvPr id="3" name="Picture 2" descr="anomaly.png"/>
+          <p:cNvPicPr>
+            <a:picLocks noChangeAspect="1"/>
+          </p:cNvPicPr>
+          <p:nvPr/>
+        </p:nvPicPr>
+        <p:blipFill>
+          <a:blip r:embed="rId2"/>
+          <a:stretch>
+            <a:fillRect/>
+          </a:stretch>
+        </p:blipFill>
+        <p:spPr>
+          <a:xfrm>
+            <a:off x="457200" y="1188720"/>
+            <a:ext cx="11247120" cy="4600373"/>
+          </a:xfrm>
+          <a:prstGeom prst="rect">
+            <a:avLst/>
+          </a:prstGeom>
+        </p:spPr>
+      </p:pic>
     </p:spTree>
   </p:cSld>
   <p:clrMapOvr>
@@ -8895,7 +8829,7 @@
             <a:spLocks noGrp="1"/>
           </p:cNvSpPr>
           <p:nvPr>
-            <p:ph type="body" idx="13" sz="quarter"/>
+            <p:ph type="body" idx="14" sz="quarter"/>
           </p:nvPr>
         </p:nvSpPr>
         <p:spPr/>
@@ -8904,12 +8838,7 @@
           <a:lstStyle/>
           <a:p>
             <a:r>
-              <a:t>Limitations &amp;</a:t>
-            </a:r>
-          </a:p>
-          <a:p>
-            <a:r>
-              <a:t>Workshop</a:t>
+              <a:t/>
             </a:r>
           </a:p>
         </p:txBody>
@@ -8917,6 +8846,73 @@
       <p:sp>
         <p:nvSpPr>
           <p:cNvPr id="3" name="Text Placeholder 2"/>
+          <p:cNvSpPr>
+            <a:spLocks noGrp="1"/>
+          </p:cNvSpPr>
+          <p:nvPr>
+            <p:ph type="body" idx="15" sz="quarter"/>
+          </p:nvPr>
+        </p:nvSpPr>
+        <p:spPr/>
+        <p:txBody>
+          <a:bodyPr/>
+          <a:lstStyle/>
+          <a:p>
+            <a:r>
+              <a:rPr sz="1400"/>
+              <a:t>This is the foundation</a:t>
+            </a:r>
+          </a:p>
+          <a:p>
+            <a:r>
+              <a:rPr sz="1400"/>
+              <a:t>of anomaly detection:</a:t>
+            </a:r>
+          </a:p>
+          <a:p>
+            <a:r>
+              <a:rPr sz="1400"/>
+              <a:t>build a baseline of</a:t>
+            </a:r>
+          </a:p>
+          <a:p>
+            <a:r>
+              <a:rPr sz="1400"/>
+              <a:t>'normal', then flag</a:t>
+            </a:r>
+          </a:p>
+          <a:p>
+            <a:r>
+              <a:rPr sz="1400"/>
+              <a:t>deviations.</a:t>
+            </a:r>
+          </a:p>
+        </p:txBody>
+      </p:sp>
+      <p:sp>
+        <p:nvSpPr>
+          <p:cNvPr id="4" name="Title 3"/>
+          <p:cNvSpPr>
+            <a:spLocks noGrp="1"/>
+          </p:cNvSpPr>
+          <p:nvPr>
+            <p:ph type="title"/>
+          </p:nvPr>
+        </p:nvSpPr>
+        <p:spPr/>
+        <p:txBody>
+          <a:bodyPr/>
+          <a:lstStyle/>
+          <a:p>
+            <a:r>
+              <a:t>How the Anomaly Baseline Works</a:t>
+            </a:r>
+          </a:p>
+        </p:txBody>
+      </p:sp>
+      <p:sp>
+        <p:nvSpPr>
+          <p:cNvPr id="5" name="Text Placeholder 4"/>
           <p:cNvSpPr>
             <a:spLocks noGrp="1"/>
           </p:cNvSpPr>
@@ -8930,7 +8926,56 @@
           <a:lstStyle/>
           <a:p>
             <a:r>
-              <a:t>06</a:t>
+              <a:rPr sz="1400"/>
+              <a:t>1. Train on normal traffic only</a:t>
+            </a:r>
+          </a:p>
+          <a:p>
+            <a:r>
+              <a:rPr sz="1400"/>
+              <a:t>2. For each new connection:</a:t>
+            </a:r>
+          </a:p>
+          <a:p>
+            <a:r>
+              <a:rPr sz="1400"/>
+              <a:t>   predicted = model.predict(req_per_sec)</a:t>
+            </a:r>
+          </a:p>
+          <a:p>
+            <a:r>
+              <a:rPr sz="1400"/>
+              <a:t>   residual = actual - predicted</a:t>
+            </a:r>
+          </a:p>
+          <a:p>
+            <a:r>
+              <a:rPr sz="1400"/>
+              <a:t>3. If residual &gt; threshold: FLAG</a:t>
+            </a:r>
+          </a:p>
+          <a:p>
+            <a:r>
+              <a:rPr sz="1400"/>
+              <a:t/>
+            </a:r>
+          </a:p>
+          <a:p>
+            <a:r>
+              <a:rPr sz="1400"/>
+              <a:t>Threshold = 2 x RMSE works well</a:t>
+            </a:r>
+          </a:p>
+          <a:p>
+            <a:r>
+              <a:rPr sz="1400"/>
+              <a:t>Residual of 700ms when expected 250ms</a:t>
+            </a:r>
+          </a:p>
+          <a:p>
+            <a:r>
+              <a:rPr sz="1400"/>
+              <a:t>  = clear anomaly</a:t>
             </a:r>
           </a:p>
         </p:txBody>
@@ -8955,12 +9000,12 @@
       <p:grpSpPr/>
       <p:sp>
         <p:nvSpPr>
-          <p:cNvPr id="2" name="Title 1"/>
+          <p:cNvPr id="2" name="Text Placeholder 1"/>
           <p:cNvSpPr>
             <a:spLocks noGrp="1"/>
           </p:cNvSpPr>
           <p:nvPr>
-            <p:ph type="title"/>
+            <p:ph type="body" idx="13" sz="quarter"/>
           </p:nvPr>
         </p:nvSpPr>
         <p:spPr/>
@@ -8969,35 +9014,37 @@
           <a:lstStyle/>
           <a:p>
             <a:r>
-              <a:t>Limitation — Real Servers Are Non-Linear</a:t>
-            </a:r>
-          </a:p>
-        </p:txBody>
-      </p:sp>
-      <p:pic>
-        <p:nvPicPr>
-          <p:cNvPr id="3" name="Picture 2" descr="lr_limitation.png"/>
-          <p:cNvPicPr>
-            <a:picLocks noChangeAspect="1"/>
-          </p:cNvPicPr>
-          <p:nvPr/>
-        </p:nvPicPr>
-        <p:blipFill>
-          <a:blip r:embed="rId2"/>
-          <a:stretch>
-            <a:fillRect/>
-          </a:stretch>
-        </p:blipFill>
-        <p:spPr>
-          <a:xfrm>
-            <a:off x="2011680" y="1371600"/>
-            <a:ext cx="8229600" cy="4780429"/>
-          </a:xfrm>
-          <a:prstGeom prst="rect">
-            <a:avLst/>
-          </a:prstGeom>
-        </p:spPr>
-      </p:pic>
+              <a:t>Limitations</a:t>
+            </a:r>
+          </a:p>
+          <a:p>
+            <a:r>
+              <a:t>and Next Steps</a:t>
+            </a:r>
+          </a:p>
+        </p:txBody>
+      </p:sp>
+      <p:sp>
+        <p:nvSpPr>
+          <p:cNvPr id="3" name="Text Placeholder 2"/>
+          <p:cNvSpPr>
+            <a:spLocks noGrp="1"/>
+          </p:cNvSpPr>
+          <p:nvPr>
+            <p:ph type="body" idx="16" sz="quarter"/>
+          </p:nvPr>
+        </p:nvSpPr>
+        <p:spPr/>
+        <p:txBody>
+          <a:bodyPr/>
+          <a:lstStyle/>
+          <a:p>
+            <a:r>
+              <a:t>05</a:t>
+            </a:r>
+          </a:p>
+        </p:txBody>
+      </p:sp>
     </p:spTree>
   </p:cSld>
   <p:clrMapOvr>
@@ -9032,66 +9079,35 @@
           <a:lstStyle/>
           <a:p>
             <a:r>
-              <a:t>Workshop — 4 Exercises</a:t>
-            </a:r>
-          </a:p>
-        </p:txBody>
-      </p:sp>
-      <p:sp>
-        <p:nvSpPr>
-          <p:cNvPr id="3" name="Content Placeholder 2"/>
-          <p:cNvSpPr>
-            <a:spLocks noGrp="1"/>
-          </p:cNvSpPr>
-          <p:nvPr>
-            <p:ph idx="1"/>
-          </p:nvPr>
-        </p:nvSpPr>
-        <p:spPr/>
-        <p:txBody>
-          <a:bodyPr/>
-          <a:lstStyle/>
-          <a:p>
-            <a:pPr/>
-            <a:r>
-              <a:t>Exercise 1: Understanding regression — the dataset, visualising the relationship</a:t>
-            </a:r>
-          </a:p>
-          <a:p>
-            <a:pPr/>
-            <a:r>
-              <a:t>Exercise 2: Train/test split — why we split, the danger of evaluating on training data</a:t>
-            </a:r>
-          </a:p>
-          <a:p>
-            <a:pPr/>
-            <a:r>
-              <a:t>Exercise 3: Fit and predict — model.fit(), slope/intercept, visualise the line</a:t>
-            </a:r>
-          </a:p>
-          <a:p>
-            <a:pPr/>
-            <a:r>
-              <a:t>Exercise 4: Evaluate — MSE, RMSE, MAE, R², build a security baseline</a:t>
-            </a:r>
-          </a:p>
-          <a:p>
-            <a:pPr/>
-          </a:p>
-          <a:p>
-            <a:pPr/>
-            <a:r>
-              <a:t>Each exercise: lecture.md → handson.md → solution_linear_regression.py</a:t>
-            </a:r>
-          </a:p>
-          <a:p>
-            <a:pPr/>
-            <a:r>
-              <a:t>Run your script after each step — verify output before moving on</a:t>
-            </a:r>
-          </a:p>
-        </p:txBody>
-      </p:sp>
+              <a:t>Limitation: Only Captures Linear Relationships</a:t>
+            </a:r>
+          </a:p>
+        </p:txBody>
+      </p:sp>
+      <p:pic>
+        <p:nvPicPr>
+          <p:cNvPr id="3" name="Picture 2" descr="nonlinear.png"/>
+          <p:cNvPicPr>
+            <a:picLocks noChangeAspect="1"/>
+          </p:cNvPicPr>
+          <p:nvPr/>
+        </p:nvPicPr>
+        <p:blipFill>
+          <a:blip r:embed="rId2"/>
+          <a:stretch>
+            <a:fillRect/>
+          </a:stretch>
+        </p:blipFill>
+        <p:spPr>
+          <a:xfrm>
+            <a:off x="640080" y="1371600"/>
+            <a:ext cx="10972800" cy="4395883"/>
+          </a:xfrm>
+          <a:prstGeom prst="rect">
+            <a:avLst/>
+          </a:prstGeom>
+        </p:spPr>
+      </p:pic>
     </p:spTree>
   </p:cSld>
   <p:clrMapOvr>
@@ -9112,65 +9128,7 @@
       <p:grpSpPr/>
       <p:sp>
         <p:nvSpPr>
-          <p:cNvPr id="2" name="Text Placeholder 1"/>
-          <p:cNvSpPr>
-            <a:spLocks noGrp="1"/>
-          </p:cNvSpPr>
-          <p:nvPr>
-            <p:ph type="body" idx="12" sz="quarter"/>
-          </p:nvPr>
-        </p:nvSpPr>
-        <p:spPr/>
-        <p:txBody>
-          <a:bodyPr/>
-          <a:lstStyle/>
-          <a:p>
-            <a:pPr/>
-            <a:r>
-              <a:t>Linear regression predicts a continuous value: y = weight × x + bias</a:t>
-            </a:r>
-          </a:p>
-          <a:p>
-            <a:pPr/>
-            <a:r>
-              <a:t>The model learns weight and bias by minimising prediction error</a:t>
-            </a:r>
-          </a:p>
-          <a:p>
-            <a:pPr/>
-            <a:r>
-              <a:t>R² measures fit quality; RMSE measures average error in real units</a:t>
-            </a:r>
-          </a:p>
-          <a:p>
-            <a:pPr/>
-            <a:r>
-              <a:t>Always split data into train/test before fitting</a:t>
-            </a:r>
-          </a:p>
-          <a:p>
-            <a:pPr/>
-            <a:r>
-              <a:t>Security use: build a baseline, flag anomalies when actual &gt;&gt; predicted</a:t>
-            </a:r>
-          </a:p>
-          <a:p>
-            <a:pPr/>
-            <a:r>
-              <a:t>Limitation: only captures linear relationships — neural networks handle the rest</a:t>
-            </a:r>
-          </a:p>
-          <a:p>
-            <a:pPr/>
-            <a:r>
-              <a:t>Next: Lesson 1.3 — Logistic Regression (binary classification)</a:t>
-            </a:r>
-          </a:p>
-        </p:txBody>
-      </p:sp>
-      <p:sp>
-        <p:nvSpPr>
-          <p:cNvPr id="3" name="Title 2"/>
+          <p:cNvPr id="2" name="Title 1"/>
           <p:cNvSpPr>
             <a:spLocks noGrp="1"/>
           </p:cNvSpPr>
@@ -9184,7 +9142,65 @@
           <a:lstStyle/>
           <a:p>
             <a:r>
-              <a:t>Summary</a:t>
+              <a:t>Workshop: 4 Hands-On Exercises</a:t>
+            </a:r>
+          </a:p>
+        </p:txBody>
+      </p:sp>
+      <p:sp>
+        <p:nvSpPr>
+          <p:cNvPr id="3" name="Content Placeholder 2"/>
+          <p:cNvSpPr>
+            <a:spLocks noGrp="1"/>
+          </p:cNvSpPr>
+          <p:nvPr>
+            <p:ph idx="1"/>
+          </p:nvPr>
+        </p:nvSpPr>
+        <p:spPr/>
+        <p:txBody>
+          <a:bodyPr/>
+          <a:lstStyle/>
+          <a:p>
+            <a:r>
+              <a:rPr sz="1600"/>
+              <a:t>Exercise 1:  Regression vs classification - explore the dataset</a:t>
+            </a:r>
+          </a:p>
+          <a:p>
+            <a:r>
+              <a:rPr sz="1600"/>
+              <a:t>Exercise 2:  Train/test split - why we hold out data</a:t>
+            </a:r>
+          </a:p>
+          <a:p>
+            <a:r>
+              <a:rPr sz="1600"/>
+              <a:t>Exercise 3:  Fit and predict - train the model, plot the line</a:t>
+            </a:r>
+          </a:p>
+          <a:p>
+            <a:r>
+              <a:rPr sz="1600"/>
+              <a:t>Exercise 4:  Evaluate - R-squared, RMSE, MAE, build a security baseline</a:t>
+            </a:r>
+          </a:p>
+          <a:p>
+            <a:r>
+              <a:rPr sz="1600"/>
+              <a:t/>
+            </a:r>
+          </a:p>
+          <a:p>
+            <a:r>
+              <a:rPr sz="1600"/>
+              <a:t>Each exercise: lecture.md (concept) + handson.md (build it yourself)</a:t>
+            </a:r>
+          </a:p>
+          <a:p>
+            <a:r>
+              <a:rPr sz="1600"/>
+              <a:t>Solution files provided to check your work</a:t>
             </a:r>
           </a:p>
         </p:txBody>
@@ -9222,51 +9238,39 @@
           <a:bodyPr/>
           <a:lstStyle/>
           <a:p>
-            <a:pPr/>
-            <a:r>
-              <a:t>Predicting a number — regression vs classification</a:t>
-            </a:r>
-          </a:p>
-          <a:p>
-            <a:pPr/>
-            <a:r>
-              <a:t>The equation: y = weight × x + bias</a:t>
-            </a:r>
-          </a:p>
-          <a:p>
-            <a:pPr/>
-            <a:r>
-              <a:t>Real-life example: server response time</a:t>
-            </a:r>
-          </a:p>
-          <a:p>
-            <a:pPr/>
-            <a:r>
-              <a:t>Train/test split and model fitting</a:t>
-            </a:r>
-          </a:p>
-          <a:p>
-            <a:pPr/>
-            <a:r>
-              <a:t>Evaluation: R², RMSE, MAE</a:t>
-            </a:r>
-          </a:p>
-          <a:p>
-            <a:pPr/>
-            <a:r>
-              <a:t>Security application: DoS anomaly detection</a:t>
-            </a:r>
-          </a:p>
-          <a:p>
-            <a:pPr/>
-            <a:r>
-              <a:t>Limitations of linear models</a:t>
-            </a:r>
-          </a:p>
-          <a:p>
-            <a:pPr/>
-            <a:r>
-              <a:t>Workshop: 4 hands-on exercises</a:t>
+            <a:r>
+              <a:rPr sz="1600"/>
+              <a:t>Regression vs classification - predicting numbers</a:t>
+            </a:r>
+          </a:p>
+          <a:p>
+            <a:r>
+              <a:rPr sz="1600"/>
+              <a:t>The equation: y = coefficient x x + intercept</a:t>
+            </a:r>
+          </a:p>
+          <a:p>
+            <a:r>
+              <a:rPr sz="1600"/>
+              <a:t>Fitting a model to server performance data</a:t>
+            </a:r>
+          </a:p>
+          <a:p>
+            <a:r>
+              <a:rPr sz="1600"/>
+              <a:t>Evaluation metrics: R-squared, RMSE, MAE</a:t>
+            </a:r>
+          </a:p>
+          <a:p>
+            <a:r>
+              <a:rPr sz="1600"/>
+              <a:t>Security application: anomaly detection baseline</a:t>
+            </a:r>
+          </a:p>
+          <a:p>
+            <a:r>
+              <a:rPr sz="1600"/>
+              <a:t>Limitations and what comes next</a:t>
             </a:r>
           </a:p>
         </p:txBody>
@@ -9287,7 +9291,7 @@
           <a:lstStyle/>
           <a:p>
             <a:r>
-              <a:t>Agenda</a:t>
+              <a:t>What We'll Cover</a:t>
             </a:r>
           </a:p>
         </p:txBody>
@@ -9317,6 +9321,102 @@
             <a:spLocks noGrp="1"/>
           </p:cNvSpPr>
           <p:nvPr>
+            <p:ph type="body" idx="12" sz="quarter"/>
+          </p:nvPr>
+        </p:nvSpPr>
+        <p:spPr/>
+        <p:txBody>
+          <a:bodyPr/>
+          <a:lstStyle/>
+          <a:p>
+            <a:r>
+              <a:rPr sz="1500"/>
+              <a:t>Linear regression predicts a number: y = coefficient x x + intercept</a:t>
+            </a:r>
+          </a:p>
+          <a:p>
+            <a:r>
+              <a:rPr sz="1500"/>
+              <a:t>The model learns just two values: slope and intercept</a:t>
+            </a:r>
+          </a:p>
+          <a:p>
+            <a:r>
+              <a:rPr sz="1500"/>
+              <a:t>R-squared, RMSE, and MAE measure how well the line fits</a:t>
+            </a:r>
+          </a:p>
+          <a:p>
+            <a:r>
+              <a:rPr sz="1500"/>
+              <a:t>A trained baseline flags anomalous response times (possible DoS)</a:t>
+            </a:r>
+          </a:p>
+          <a:p>
+            <a:r>
+              <a:rPr sz="1500"/>
+              <a:t>Limitation: only works for linear relationships</a:t>
+            </a:r>
+          </a:p>
+          <a:p>
+            <a:r>
+              <a:rPr sz="1500"/>
+              <a:t>Next: Logistic Regression - from numbers to yes/no decisions</a:t>
+            </a:r>
+          </a:p>
+        </p:txBody>
+      </p:sp>
+      <p:sp>
+        <p:nvSpPr>
+          <p:cNvPr id="3" name="Title 2"/>
+          <p:cNvSpPr>
+            <a:spLocks noGrp="1"/>
+          </p:cNvSpPr>
+          <p:nvPr>
+            <p:ph type="title"/>
+          </p:nvPr>
+        </p:nvSpPr>
+        <p:spPr/>
+        <p:txBody>
+          <a:bodyPr/>
+          <a:lstStyle/>
+          <a:p>
+            <a:r>
+              <a:t>Key</a:t>
+            </a:r>
+          </a:p>
+          <a:p>
+            <a:r>
+              <a:t>Takeaways</a:t>
+            </a:r>
+          </a:p>
+        </p:txBody>
+      </p:sp>
+    </p:spTree>
+  </p:cSld>
+  <p:clrMapOvr>
+    <a:masterClrMapping/>
+  </p:clrMapOvr>
+</p:sld>
+</file>
+
+<file path=ppt/slides/slide21.xml><?xml version="1.0" encoding="utf-8"?>
+<p:sld xmlns:a="http://schemas.openxmlformats.org/drawingml/2006/main" xmlns:p="http://schemas.openxmlformats.org/presentationml/2006/main" xmlns:r="http://schemas.openxmlformats.org/officeDocument/2006/relationships">
+  <p:cSld>
+    <p:spTree>
+      <p:nvGrpSpPr>
+        <p:cNvPr id="1" name=""/>
+        <p:cNvGrpSpPr/>
+        <p:nvPr/>
+      </p:nvGrpSpPr>
+      <p:grpSpPr/>
+      <p:sp>
+        <p:nvSpPr>
+          <p:cNvPr id="2" name="Text Placeholder 1"/>
+          <p:cNvSpPr>
+            <a:spLocks noGrp="1"/>
+          </p:cNvSpPr>
+          <p:nvPr>
             <p:ph type="body" idx="13" sz="quarter"/>
           </p:nvPr>
         </p:nvSpPr>
@@ -9326,7 +9426,7 @@
           <a:lstStyle/>
           <a:p>
             <a:r>
-              <a:t>Next → Lesson 1.3: Logistic Regression</a:t>
+              <a:t>Next:  Lesson 1.3 - Logistic Regression</a:t>
             </a:r>
           </a:p>
         </p:txBody>
@@ -9386,12 +9486,12 @@
           <a:lstStyle/>
           <a:p>
             <a:r>
-              <a:t>Predicting</a:t>
-            </a:r>
-          </a:p>
-          <a:p>
-            <a:r>
-              <a:t>a Number</a:t>
+              <a:t>Regression</a:t>
+            </a:r>
+          </a:p>
+          <a:p>
+            <a:r>
+              <a:t>Fundamentals</a:t>
             </a:r>
           </a:p>
         </p:txBody>
@@ -9451,127 +9551,35 @@
           <a:lstStyle/>
           <a:p>
             <a:r>
-              <a:t>Regression vs Classification</a:t>
-            </a:r>
-          </a:p>
-        </p:txBody>
-      </p:sp>
-      <p:sp>
-        <p:nvSpPr>
-          <p:cNvPr id="3" name="Content Placeholder 2"/>
-          <p:cNvSpPr>
-            <a:spLocks noGrp="1"/>
-          </p:cNvSpPr>
-          <p:nvPr>
-            <p:ph idx="2" sz="half"/>
-          </p:nvPr>
-        </p:nvSpPr>
-        <p:spPr/>
-        <p:txBody>
-          <a:bodyPr/>
-          <a:lstStyle/>
-          <a:p>
-            <a:pPr/>
-            <a:r>
-              <a:t>Regression</a:t>
-            </a:r>
-          </a:p>
-          <a:p>
-            <a:pPr/>
-          </a:p>
-          <a:p>
-            <a:pPr/>
-            <a:r>
-              <a:t>Predicts a continuous number</a:t>
-            </a:r>
-          </a:p>
-          <a:p>
-            <a:pPr lvl="1"/>
-            <a:r>
-              <a:t>How many milliseconds?</a:t>
-            </a:r>
-          </a:p>
-          <a:p>
-            <a:pPr lvl="1"/>
-            <a:r>
-              <a:t>How many bytes?</a:t>
-            </a:r>
-          </a:p>
-          <a:p>
-            <a:pPr lvl="1"/>
-            <a:r>
-              <a:t>What temperature?</a:t>
-            </a:r>
-          </a:p>
-          <a:p>
-            <a:pPr/>
-          </a:p>
-          <a:p>
-            <a:pPr/>
-            <a:r>
-              <a:t>Output: 142.7 ms</a:t>
-            </a:r>
-          </a:p>
-        </p:txBody>
-      </p:sp>
-      <p:sp>
-        <p:nvSpPr>
-          <p:cNvPr id="4" name="Content Placeholder 3"/>
-          <p:cNvSpPr>
-            <a:spLocks noGrp="1"/>
-          </p:cNvSpPr>
-          <p:nvPr>
-            <p:ph idx="12" sz="half"/>
-          </p:nvPr>
-        </p:nvSpPr>
-        <p:spPr/>
-        <p:txBody>
-          <a:bodyPr/>
-          <a:lstStyle/>
-          <a:p>
-            <a:pPr/>
-            <a:r>
-              <a:t>Classification (Lesson 1.3)</a:t>
-            </a:r>
-          </a:p>
-          <a:p>
-            <a:pPr/>
-          </a:p>
-          <a:p>
-            <a:pPr/>
-            <a:r>
-              <a:t>Predicts a category</a:t>
-            </a:r>
-          </a:p>
-          <a:p>
-            <a:pPr lvl="1"/>
-            <a:r>
-              <a:t>Phishing or legitimate?</a:t>
-            </a:r>
-          </a:p>
-          <a:p>
-            <a:pPr lvl="1"/>
-            <a:r>
-              <a:t>Malware or benign?</a:t>
-            </a:r>
-          </a:p>
-          <a:p>
-            <a:pPr lvl="1"/>
-            <a:r>
-              <a:t>Attack or normal?</a:t>
-            </a:r>
-          </a:p>
-          <a:p>
-            <a:pPr/>
-          </a:p>
-          <a:p>
-            <a:pPr/>
-            <a:r>
-              <a:t>Output: phishing (87%)</a:t>
-            </a:r>
-          </a:p>
-        </p:txBody>
-      </p:sp>
+              <a:t>Two Types of Prediction</a:t>
+            </a:r>
+          </a:p>
+        </p:txBody>
+      </p:sp>
+      <p:pic>
+        <p:nvPicPr>
+          <p:cNvPr id="3" name="Picture 2" descr="reg_vs_class.png"/>
+          <p:cNvPicPr>
+            <a:picLocks noChangeAspect="1"/>
+          </p:cNvPicPr>
+          <p:nvPr/>
+        </p:nvPicPr>
+        <p:blipFill>
+          <a:blip r:embed="rId2"/>
+          <a:stretch>
+            <a:fillRect/>
+          </a:stretch>
+        </p:blipFill>
+        <p:spPr>
+          <a:xfrm>
+            <a:off x="457200" y="1371600"/>
+            <a:ext cx="11247120" cy="3646858"/>
+          </a:xfrm>
+          <a:prstGeom prst="rect">
+            <a:avLst/>
+          </a:prstGeom>
+        </p:spPr>
+      </p:pic>
     </p:spTree>
   </p:cSld>
   <p:clrMapOvr>
@@ -9606,35 +9614,139 @@
           <a:lstStyle/>
           <a:p>
             <a:r>
-              <a:t>The Equation Behind Linear Regression</a:t>
-            </a:r>
-          </a:p>
-        </p:txBody>
-      </p:sp>
-      <p:pic>
-        <p:nvPicPr>
-          <p:cNvPr id="3" name="Picture 2" descr="lr_equation.png"/>
-          <p:cNvPicPr>
-            <a:picLocks noChangeAspect="1"/>
-          </p:cNvPicPr>
-          <p:nvPr/>
-        </p:nvPicPr>
-        <p:blipFill>
-          <a:blip r:embed="rId2"/>
-          <a:stretch>
-            <a:fillRect/>
-          </a:stretch>
-        </p:blipFill>
-        <p:spPr>
-          <a:xfrm>
-            <a:off x="1371600" y="1645920"/>
-            <a:ext cx="9418320" cy="2569875"/>
-          </a:xfrm>
-          <a:prstGeom prst="rect">
-            <a:avLst/>
-          </a:prstGeom>
-        </p:spPr>
-      </p:pic>
+              <a:t>Regression vs Classification</a:t>
+            </a:r>
+          </a:p>
+        </p:txBody>
+      </p:sp>
+      <p:sp>
+        <p:nvSpPr>
+          <p:cNvPr id="3" name="Content Placeholder 2"/>
+          <p:cNvSpPr>
+            <a:spLocks noGrp="1"/>
+          </p:cNvSpPr>
+          <p:nvPr>
+            <p:ph idx="2" sz="half"/>
+          </p:nvPr>
+        </p:nvSpPr>
+        <p:spPr/>
+        <p:txBody>
+          <a:bodyPr/>
+          <a:lstStyle/>
+          <a:p>
+            <a:r>
+              <a:rPr sz="1400"/>
+              <a:t>Regression</a:t>
+            </a:r>
+          </a:p>
+          <a:p>
+            <a:r>
+              <a:rPr sz="1400"/>
+              <a:t/>
+            </a:r>
+          </a:p>
+          <a:p>
+            <a:r>
+              <a:rPr sz="1400"/>
+              <a:t>Output: a continuous number</a:t>
+            </a:r>
+          </a:p>
+          <a:p>
+            <a:r>
+              <a:rPr sz="1400"/>
+              <a:t>  Response time: 247.3 ms</a:t>
+            </a:r>
+          </a:p>
+          <a:p>
+            <a:r>
+              <a:rPr sz="1400"/>
+              <a:t>  Bandwidth: 14.2 Mbps</a:t>
+            </a:r>
+          </a:p>
+          <a:p>
+            <a:r>
+              <a:rPr sz="1400"/>
+              <a:t>  Risk score: 0.73</a:t>
+            </a:r>
+          </a:p>
+          <a:p>
+            <a:r>
+              <a:rPr sz="1400"/>
+              <a:t/>
+            </a:r>
+          </a:p>
+          <a:p>
+            <a:r>
+              <a:rPr sz="1400"/>
+              <a:t>Question: 'How much?'</a:t>
+            </a:r>
+          </a:p>
+        </p:txBody>
+      </p:sp>
+      <p:sp>
+        <p:nvSpPr>
+          <p:cNvPr id="4" name="Content Placeholder 3"/>
+          <p:cNvSpPr>
+            <a:spLocks noGrp="1"/>
+          </p:cNvSpPr>
+          <p:nvPr>
+            <p:ph idx="12" sz="half"/>
+          </p:nvPr>
+        </p:nvSpPr>
+        <p:spPr/>
+        <p:txBody>
+          <a:bodyPr/>
+          <a:lstStyle/>
+          <a:p>
+            <a:r>
+              <a:rPr sz="1400"/>
+              <a:t>Classification</a:t>
+            </a:r>
+          </a:p>
+          <a:p>
+            <a:r>
+              <a:rPr sz="1400"/>
+              <a:t/>
+            </a:r>
+          </a:p>
+          <a:p>
+            <a:r>
+              <a:rPr sz="1400"/>
+              <a:t>Output: a category / label</a:t>
+            </a:r>
+          </a:p>
+          <a:p>
+            <a:r>
+              <a:rPr sz="1400"/>
+              <a:t>  Attack or benign</a:t>
+            </a:r>
+          </a:p>
+          <a:p>
+            <a:r>
+              <a:rPr sz="1400"/>
+              <a:t>  Phishing or legitimate</a:t>
+            </a:r>
+          </a:p>
+          <a:p>
+            <a:r>
+              <a:rPr sz="1400"/>
+              <a:t>  Malware family A, B, or C</a:t>
+            </a:r>
+          </a:p>
+          <a:p>
+            <a:r>
+              <a:rPr sz="1400"/>
+              <a:t/>
+            </a:r>
+          </a:p>
+          <a:p>
+            <a:r>
+              <a:rPr sz="1400"/>
+              <a:t>Question: 'Which one?'</a:t>
+            </a:r>
+          </a:p>
+        </p:txBody>
+      </p:sp>
     </p:spTree>
   </p:cSld>
   <p:clrMapOvr>
@@ -9655,12 +9767,12 @@
       <p:grpSpPr/>
       <p:sp>
         <p:nvSpPr>
-          <p:cNvPr id="2" name="Text Placeholder 1"/>
+          <p:cNvPr id="2" name="Title 1"/>
           <p:cNvSpPr>
             <a:spLocks noGrp="1"/>
           </p:cNvSpPr>
           <p:nvPr>
-            <p:ph type="body" idx="13" sz="quarter"/>
+            <p:ph type="title"/>
           </p:nvPr>
         </p:nvSpPr>
         <p:spPr/>
@@ -9669,37 +9781,35 @@
           <a:lstStyle/>
           <a:p>
             <a:r>
-              <a:t>Server Response</a:t>
-            </a:r>
-          </a:p>
-          <a:p>
-            <a:r>
-              <a:t>Time</a:t>
-            </a:r>
-          </a:p>
-        </p:txBody>
-      </p:sp>
-      <p:sp>
-        <p:nvSpPr>
-          <p:cNvPr id="3" name="Text Placeholder 2"/>
-          <p:cNvSpPr>
-            <a:spLocks noGrp="1"/>
-          </p:cNvSpPr>
-          <p:nvPr>
-            <p:ph type="body" idx="16" sz="quarter"/>
-          </p:nvPr>
-        </p:nvSpPr>
-        <p:spPr/>
-        <p:txBody>
-          <a:bodyPr/>
-          <a:lstStyle/>
-          <a:p>
-            <a:r>
-              <a:t>02</a:t>
-            </a:r>
-          </a:p>
-        </p:txBody>
-      </p:sp>
+              <a:t>The Linear Regression Equation</a:t>
+            </a:r>
+          </a:p>
+        </p:txBody>
+      </p:sp>
+      <p:pic>
+        <p:nvPicPr>
+          <p:cNvPr id="3" name="Picture 2" descr="equation.png"/>
+          <p:cNvPicPr>
+            <a:picLocks noChangeAspect="1"/>
+          </p:cNvPicPr>
+          <p:nvPr/>
+        </p:nvPicPr>
+        <p:blipFill>
+          <a:blip r:embed="rId2"/>
+          <a:stretch>
+            <a:fillRect/>
+          </a:stretch>
+        </p:blipFill>
+        <p:spPr>
+          <a:xfrm>
+            <a:off x="640080" y="1645920"/>
+            <a:ext cx="10972800" cy="3324244"/>
+          </a:xfrm>
+          <a:prstGeom prst="rect">
+            <a:avLst/>
+          </a:prstGeom>
+        </p:spPr>
+      </p:pic>
     </p:spTree>
   </p:cSld>
   <p:clrMapOvr>
@@ -9720,12 +9830,12 @@
       <p:grpSpPr/>
       <p:sp>
         <p:nvSpPr>
-          <p:cNvPr id="2" name="Title 1"/>
+          <p:cNvPr id="2" name="Text Placeholder 1"/>
           <p:cNvSpPr>
             <a:spLocks noGrp="1"/>
           </p:cNvSpPr>
           <p:nvPr>
-            <p:ph type="title"/>
+            <p:ph type="body" idx="13" sz="quarter"/>
           </p:nvPr>
         </p:nvSpPr>
         <p:spPr/>
@@ -9734,35 +9844,37 @@
           <a:lstStyle/>
           <a:p>
             <a:r>
-              <a:t>Fitting a Line Through Server Performance Data</a:t>
-            </a:r>
-          </a:p>
-        </p:txBody>
-      </p:sp>
-      <p:pic>
-        <p:nvPicPr>
-          <p:cNvPr id="3" name="Picture 2" descr="lr_scatter.png"/>
-          <p:cNvPicPr>
-            <a:picLocks noChangeAspect="1"/>
-          </p:cNvPicPr>
-          <p:nvPr/>
-        </p:nvPicPr>
-        <p:blipFill>
-          <a:blip r:embed="rId2"/>
-          <a:stretch>
-            <a:fillRect/>
-          </a:stretch>
-        </p:blipFill>
-        <p:spPr>
-          <a:xfrm>
-            <a:off x="2011680" y="1371600"/>
-            <a:ext cx="8229600" cy="5026843"/>
-          </a:xfrm>
-          <a:prstGeom prst="rect">
-            <a:avLst/>
-          </a:prstGeom>
-        </p:spPr>
-      </p:pic>
+              <a:t>The Scenario:</a:t>
+            </a:r>
+          </a:p>
+          <a:p>
+            <a:r>
+              <a:t>Server Response Time</a:t>
+            </a:r>
+          </a:p>
+        </p:txBody>
+      </p:sp>
+      <p:sp>
+        <p:nvSpPr>
+          <p:cNvPr id="3" name="Text Placeholder 2"/>
+          <p:cNvSpPr>
+            <a:spLocks noGrp="1"/>
+          </p:cNvSpPr>
+          <p:nvPr>
+            <p:ph type="body" idx="16" sz="quarter"/>
+          </p:nvPr>
+        </p:nvSpPr>
+        <p:spPr/>
+        <p:txBody>
+          <a:bodyPr/>
+          <a:lstStyle/>
+          <a:p>
+            <a:r>
+              <a:t>02</a:t>
+            </a:r>
+          </a:p>
+        </p:txBody>
+      </p:sp>
     </p:spTree>
   </p:cSld>
   <p:clrMapOvr>
@@ -9783,65 +9895,7 @@
       <p:grpSpPr/>
       <p:sp>
         <p:nvSpPr>
-          <p:cNvPr id="2" name="Text Placeholder 1"/>
-          <p:cNvSpPr>
-            <a:spLocks noGrp="1"/>
-          </p:cNvSpPr>
-          <p:nvPr>
-            <p:ph type="body" idx="14" sz="quarter"/>
-          </p:nvPr>
-        </p:nvSpPr>
-        <p:spPr/>
-        <p:txBody>
-          <a:bodyPr/>
-          <a:lstStyle/>
-          <a:p>
-            <a:r>
-              <a:t>— Anomaly detection in action</a:t>
-            </a:r>
-          </a:p>
-        </p:txBody>
-      </p:sp>
-      <p:sp>
-        <p:nvSpPr>
-          <p:cNvPr id="3" name="Text Placeholder 2"/>
-          <p:cNvSpPr>
-            <a:spLocks noGrp="1"/>
-          </p:cNvSpPr>
-          <p:nvPr>
-            <p:ph type="body" idx="15" sz="quarter"/>
-          </p:nvPr>
-        </p:nvSpPr>
-        <p:spPr/>
-        <p:txBody>
-          <a:bodyPr/>
-          <a:lstStyle/>
-          <a:p>
-            <a:r>
-              <a:t>Predicted = 120ms</a:t>
-            </a:r>
-          </a:p>
-          <a:p>
-            <a:r>
-              <a:t>Actual = 4,000ms</a:t>
-            </a:r>
-          </a:p>
-          <a:p/>
-          <a:p>
-            <a:r>
-              <a:t>→ Possible DoS attack</a:t>
-            </a:r>
-          </a:p>
-          <a:p>
-            <a:r>
-              <a:t>or resource exhaustion</a:t>
-            </a:r>
-          </a:p>
-        </p:txBody>
-      </p:sp>
-      <p:sp>
-        <p:nvSpPr>
-          <p:cNvPr id="4" name="Title 3"/>
+          <p:cNvPr id="2" name="Title 1"/>
           <p:cNvSpPr>
             <a:spLocks noGrp="1"/>
           </p:cNvSpPr>
@@ -9855,57 +9909,35 @@
           <a:lstStyle/>
           <a:p>
             <a:r>
-              <a:t>Why This Matters for Security</a:t>
-            </a:r>
-          </a:p>
-        </p:txBody>
-      </p:sp>
-      <p:sp>
-        <p:nvSpPr>
-          <p:cNvPr id="5" name="Text Placeholder 4"/>
-          <p:cNvSpPr>
-            <a:spLocks noGrp="1"/>
-          </p:cNvSpPr>
-          <p:nvPr>
-            <p:ph type="body" idx="16" sz="quarter"/>
-          </p:nvPr>
-        </p:nvSpPr>
-        <p:spPr/>
-        <p:txBody>
-          <a:bodyPr/>
-          <a:lstStyle/>
-          <a:p>
-            <a:pPr/>
-            <a:r>
-              <a:t>Monitoring a web server under load</a:t>
-            </a:r>
-          </a:p>
-          <a:p>
-            <a:pPr/>
-            <a:r>
-              <a:t>As traffic increases, response time goes up</a:t>
-            </a:r>
-          </a:p>
-          <a:p>
-            <a:pPr/>
-            <a:r>
-              <a:t>The model learns the normal relationship</a:t>
-            </a:r>
-          </a:p>
-          <a:p>
-            <a:pPr/>
-            <a:r>
-              <a:t>Then compares actual vs predicted:</a:t>
-            </a:r>
-          </a:p>
-          <a:p>
-            <a:pPr lvl="1"/>
-            <a:r>
-              <a:t>Large gap = something is wrong</a:t>
-            </a:r>
-          </a:p>
-        </p:txBody>
-      </p:sp>
+              <a:t>Fitting a Line Through 200 Server Measurements</a:t>
+            </a:r>
+          </a:p>
+        </p:txBody>
+      </p:sp>
+      <p:pic>
+        <p:nvPicPr>
+          <p:cNvPr id="3" name="Picture 2" descr="scatter_line.png"/>
+          <p:cNvPicPr>
+            <a:picLocks noChangeAspect="1"/>
+          </p:cNvPicPr>
+          <p:nvPr/>
+        </p:nvPicPr>
+        <p:blipFill>
+          <a:blip r:embed="rId2"/>
+          <a:stretch>
+            <a:fillRect/>
+          </a:stretch>
+        </p:blipFill>
+        <p:spPr>
+          <a:xfrm>
+            <a:off x="640080" y="1280160"/>
+            <a:ext cx="10972800" cy="4903100"/>
+          </a:xfrm>
+          <a:prstGeom prst="rect">
+            <a:avLst/>
+          </a:prstGeom>
+        </p:spPr>
+      </p:pic>
     </p:spTree>
   </p:cSld>
   <p:clrMapOvr>
@@ -9931,7 +9963,7 @@
             <a:spLocks noGrp="1"/>
           </p:cNvSpPr>
           <p:nvPr>
-            <p:ph type="body" idx="13" sz="quarter"/>
+            <p:ph type="body" idx="14" sz="quarter"/>
           </p:nvPr>
         </p:nvSpPr>
         <p:spPr/>
@@ -9940,12 +9972,7 @@
           <a:lstStyle/>
           <a:p>
             <a:r>
-              <a:t>Training</a:t>
-            </a:r>
-          </a:p>
-          <a:p>
-            <a:r>
-              <a:t>the Model</a:t>
+              <a:t/>
             </a:r>
           </a:p>
         </p:txBody>
@@ -9953,6 +9980,79 @@
       <p:sp>
         <p:nvSpPr>
           <p:cNvPr id="3" name="Text Placeholder 2"/>
+          <p:cNvSpPr>
+            <a:spLocks noGrp="1"/>
+          </p:cNvSpPr>
+          <p:nvPr>
+            <p:ph type="body" idx="15" sz="quarter"/>
+          </p:nvPr>
+        </p:nvSpPr>
+        <p:spPr/>
+        <p:txBody>
+          <a:bodyPr/>
+          <a:lstStyle/>
+          <a:p>
+            <a:r>
+              <a:rPr sz="1400"/>
+              <a:t>The coefficient and intercept</a:t>
+            </a:r>
+          </a:p>
+          <a:p>
+            <a:r>
+              <a:rPr sz="1400"/>
+              <a:t>are the only two numbers</a:t>
+            </a:r>
+          </a:p>
+          <a:p>
+            <a:r>
+              <a:rPr sz="1400"/>
+              <a:t>the model learns.</a:t>
+            </a:r>
+          </a:p>
+          <a:p>
+            <a:r>
+              <a:rPr sz="1400"/>
+              <a:t/>
+            </a:r>
+          </a:p>
+          <a:p>
+            <a:r>
+              <a:rPr sz="1400"/>
+              <a:t>Everything else follows</a:t>
+            </a:r>
+          </a:p>
+          <a:p>
+            <a:r>
+              <a:rPr sz="1400"/>
+              <a:t>from these.</a:t>
+            </a:r>
+          </a:p>
+        </p:txBody>
+      </p:sp>
+      <p:sp>
+        <p:nvSpPr>
+          <p:cNvPr id="4" name="Title 3"/>
+          <p:cNvSpPr>
+            <a:spLocks noGrp="1"/>
+          </p:cNvSpPr>
+          <p:nvPr>
+            <p:ph type="title"/>
+          </p:nvPr>
+        </p:nvSpPr>
+        <p:spPr/>
+        <p:txBody>
+          <a:bodyPr/>
+          <a:lstStyle/>
+          <a:p>
+            <a:r>
+              <a:t>Reading the Model's Output</a:t>
+            </a:r>
+          </a:p>
+        </p:txBody>
+      </p:sp>
+      <p:sp>
+        <p:nvSpPr>
+          <p:cNvPr id="5" name="Text Placeholder 4"/>
           <p:cNvSpPr>
             <a:spLocks noGrp="1"/>
           </p:cNvSpPr>
@@ -9966,7 +10066,50 @@
           <a:lstStyle/>
           <a:p>
             <a:r>
-              <a:t>03</a:t>
+              <a:rPr sz="1400"/>
+              <a:t>Coefficient (slope) = 0.85</a:t>
+            </a:r>
+          </a:p>
+          <a:p>
+            <a:r>
+              <a:rPr sz="1400"/>
+              <a:t>  Every extra req/s adds 0.85 ms</a:t>
+            </a:r>
+          </a:p>
+          <a:p>
+            <a:r>
+              <a:rPr sz="1400"/>
+              <a:t/>
+            </a:r>
+          </a:p>
+          <a:p>
+            <a:r>
+              <a:rPr sz="1400"/>
+              <a:t>Intercept (bias) = 40 ms</a:t>
+            </a:r>
+          </a:p>
+          <a:p>
+            <a:r>
+              <a:rPr sz="1400"/>
+              <a:t>  Baseline latency at zero traffic</a:t>
+            </a:r>
+          </a:p>
+          <a:p>
+            <a:r>
+              <a:rPr sz="1400"/>
+              <a:t/>
+            </a:r>
+          </a:p>
+          <a:p>
+            <a:r>
+              <a:rPr sz="1400"/>
+              <a:t>To predict at 300 req/s:</a:t>
+            </a:r>
+          </a:p>
+          <a:p>
+            <a:r>
+              <a:rPr sz="1400"/>
+              <a:t>  0.85 x 300 + 40 = 295 ms</a:t>
             </a:r>
           </a:p>
         </p:txBody>

</xml_diff>